<commit_message>
docs: update ETL guide, onboarding deck, memory bank and add benchmark results
Fix bitmap query examples and update ClickHouse server address in ETL guide.
Refresh onboarding presentation. Add Phase 4 benchmark queries and query log
analysis. Update memory bank with 2026-05-27 Phase 4 progress and anchor_dt
migration.
</commit_message>
<xml_diff>
--- a/DMP_Flowable_ETL_Onboarding.pptx
+++ b/DMP_Flowable_ETL_Onboarding.pptx
@@ -4,6 +4,9 @@
   <p:sldMasterIdLst>
     <p:sldMasterId id="2147483648" r:id="rId1"/>
   </p:sldMasterIdLst>
+  <p:notesMasterIdLst>
+    <p:notesMasterId r:id="rId28"/>
+  </p:notesMasterIdLst>
   <p:sldIdLst>
     <p:sldId id="256" r:id="rId2"/>
     <p:sldId id="257" r:id="rId3"/>
@@ -32,9 +35,6 @@
     <p:sldId id="280" r:id="rId26"/>
     <p:sldId id="281" r:id="rId27"/>
   </p:sldIdLst>
-  <p:notesMasterIdLst>
-    <p:notesMasterId r:id="rId28"/>
-  </p:notesMasterIdLst>
   <p:sldSz cx="18288000" cy="10287000"/>
   <p:notesSz cx="10287000" cy="18288000"/>
   <p:defaultTextStyle>
@@ -129,6 +129,11 @@
       </a:defRPr>
     </a:lvl9pPr>
   </p:defaultTextStyle>
+  <p:extLst>
+    <p:ext uri="{EFAFB233-063F-42B5-8137-9DF3F51BA10A}">
+      <p15:sldGuideLst xmlns:p15="http://schemas.microsoft.com/office/powerpoint/2012/main"/>
+    </p:ext>
+  </p:extLst>
 </p:presentation>
 </file>
 
@@ -154,234 +159,10 @@
           <a:chExt cx="0" cy="0"/>
         </a:xfrm>
       </p:grpSpPr>
-      <p:sp>
-        <p:nvSpPr>
-          <p:cNvPr id="2" name="Header Placeholder 1"/>
-          <p:cNvSpPr>
-            <a:spLocks noGrp="1"/>
-          </p:cNvSpPr>
-          <p:nvPr>
-            <p:ph type="hdr" sz="quarter"/>
-          </p:nvPr>
-        </p:nvSpPr>
-        <p:spPr>
-          <a:xfrm>
-            <a:off x="0" y="0"/>
-            <a:ext cx="2971800" cy="458788"/>
-          </a:xfrm>
-          <a:prstGeom prst="rect">
-            <a:avLst/>
-          </a:prstGeom>
-        </p:spPr>
-        <p:txBody>
-          <a:bodyPr vert="horz" lIns="91440" tIns="45720" rIns="91440" bIns="45720" rtlCol="0"/>
-          <a:lstStyle>
-            <a:lvl1pPr algn="l">
-              <a:defRPr sz="1200"/>
-            </a:lvl1pPr>
-          </a:lstStyle>
-          <a:p>
-            <a:endParaRPr lang="en-US"/>
-          </a:p>
-        </p:txBody>
-      </p:sp>
-      <p:sp>
-        <p:nvSpPr>
-          <p:cNvPr id="3" name="Date Placeholder 2"/>
-          <p:cNvSpPr>
-            <a:spLocks noGrp="1"/>
-          </p:cNvSpPr>
-          <p:nvPr>
-            <p:ph type="dt" idx="1"/>
-          </p:nvPr>
-        </p:nvSpPr>
-        <p:spPr>
-          <a:xfrm>
-            <a:off x="3884613" y="0"/>
-            <a:ext cx="2971800" cy="458788"/>
-          </a:xfrm>
-          <a:prstGeom prst="rect">
-            <a:avLst/>
-          </a:prstGeom>
-        </p:spPr>
-        <p:txBody>
-          <a:bodyPr vert="horz" lIns="91440" tIns="45720" rIns="91440" bIns="45720" rtlCol="0"/>
-          <a:lstStyle>
-            <a:lvl1pPr algn="r">
-              <a:defRPr sz="1200"/>
-            </a:lvl1pPr>
-          </a:lstStyle>
-          <a:p>
-            <a:fld id="{5282F153-3F37-0F45-9E97-73ACFA13230C}" type="datetimeFigureOut">
-              <a:rPr lang="en-US"/>
-              <a:t>7/23/19</a:t>
-            </a:fld>
-            <a:endParaRPr lang="en-US"/>
-          </a:p>
-        </p:txBody>
-      </p:sp>
-      <p:sp>
-        <p:nvSpPr>
-          <p:cNvPr id="4" name="Slide Image Placeholder 3"/>
-          <p:cNvSpPr>
-            <a:spLocks noGrp="1" noRot="1" noChangeAspect="1"/>
-          </p:cNvSpPr>
-          <p:nvPr>
-            <p:ph type="sldImg" idx="2"/>
-          </p:nvPr>
-        </p:nvSpPr>
-        <p:spPr>
-          <a:xfrm>
-            <a:off x="685800" y="1143000"/>
-            <a:ext cx="5486400" cy="3086100"/>
-          </a:xfrm>
-          <a:prstGeom prst="rect">
-            <a:avLst/>
-          </a:prstGeom>
-          <a:noFill/>
-          <a:ln w="12700">
-            <a:solidFill>
-              <a:prstClr val="black"/>
-            </a:solidFill>
-          </a:ln>
-        </p:spPr>
-        <p:txBody>
-          <a:bodyPr vert="horz" lIns="91440" tIns="45720" rIns="91440" bIns="45720" rtlCol="0" anchor="ctr"/>
-          <a:lstStyle/>
-          <a:p>
-            <a:endParaRPr lang="en-US"/>
-          </a:p>
-        </p:txBody>
-      </p:sp>
-      <p:sp>
-        <p:nvSpPr>
-          <p:cNvPr id="5" name="Notes Placeholder 4"/>
-          <p:cNvSpPr>
-            <a:spLocks noGrp="1"/>
-          </p:cNvSpPr>
-          <p:nvPr>
-            <p:ph type="body" sz="quarter" idx="3"/>
-          </p:nvPr>
-        </p:nvSpPr>
-        <p:spPr>
-          <a:xfrm>
-            <a:off x="685800" y="4400550"/>
-            <a:ext cx="5486400" cy="3600450"/>
-          </a:xfrm>
-          <a:prstGeom prst="rect">
-            <a:avLst/>
-          </a:prstGeom>
-        </p:spPr>
-        <p:txBody>
-          <a:bodyPr vert="horz" lIns="91440" tIns="45720" rIns="91440" bIns="45720" rtlCol="0"/>
-          <a:lstStyle/>
-          <a:p>
-            <a:pPr lvl="0"/>
-            <a:r>
-              <a:rPr lang="en-US"/>
-              <a:t>Click to edit Master text styles</a:t>
-            </a:r>
-          </a:p>
-          <a:p>
-            <a:pPr lvl="1"/>
-            <a:r>
-              <a:rPr lang="en-US"/>
-              <a:t>Second level</a:t>
-            </a:r>
-          </a:p>
-          <a:p>
-            <a:pPr lvl="2"/>
-            <a:r>
-              <a:rPr lang="en-US"/>
-              <a:t>Third level</a:t>
-            </a:r>
-          </a:p>
-          <a:p>
-            <a:pPr lvl="3"/>
-            <a:r>
-              <a:rPr lang="en-US"/>
-              <a:t>Fourth level</a:t>
-            </a:r>
-          </a:p>
-          <a:p>
-            <a:pPr lvl="4"/>
-            <a:r>
-              <a:rPr lang="en-US"/>
-              <a:t>Fifth level</a:t>
-            </a:r>
-          </a:p>
-        </p:txBody>
-      </p:sp>
-      <p:sp>
-        <p:nvSpPr>
-          <p:cNvPr id="6" name="Footer Placeholder 5"/>
-          <p:cNvSpPr>
-            <a:spLocks noGrp="1"/>
-          </p:cNvSpPr>
-          <p:nvPr>
-            <p:ph type="ftr" sz="quarter" idx="4"/>
-          </p:nvPr>
-        </p:nvSpPr>
-        <p:spPr>
-          <a:xfrm>
-            <a:off x="0" y="8685213"/>
-            <a:ext cx="2971800" cy="458787"/>
-          </a:xfrm>
-          <a:prstGeom prst="rect">
-            <a:avLst/>
-          </a:prstGeom>
-        </p:spPr>
-        <p:txBody>
-          <a:bodyPr vert="horz" lIns="91440" tIns="45720" rIns="91440" bIns="45720" rtlCol="0" anchor="b"/>
-          <a:lstStyle>
-            <a:lvl1pPr algn="l">
-              <a:defRPr sz="1200"/>
-            </a:lvl1pPr>
-          </a:lstStyle>
-          <a:p>
-            <a:endParaRPr lang="en-US"/>
-          </a:p>
-        </p:txBody>
-      </p:sp>
-      <p:sp>
-        <p:nvSpPr>
-          <p:cNvPr id="7" name="Slide Number Placeholder 6"/>
-          <p:cNvSpPr>
-            <a:spLocks noGrp="1"/>
-          </p:cNvSpPr>
-          <p:nvPr>
-            <p:ph type="sldNum" sz="quarter" idx="5"/>
-          </p:nvPr>
-        </p:nvSpPr>
-        <p:spPr>
-          <a:xfrm>
-            <a:off x="3884613" y="8685213"/>
-            <a:ext cx="2971800" cy="458787"/>
-          </a:xfrm>
-          <a:prstGeom prst="rect">
-            <a:avLst/>
-          </a:prstGeom>
-        </p:spPr>
-        <p:txBody>
-          <a:bodyPr vert="horz" lIns="91440" tIns="45720" rIns="91440" bIns="45720" rtlCol="0" anchor="b"/>
-          <a:lstStyle>
-            <a:lvl1pPr algn="r">
-              <a:defRPr sz="1200"/>
-            </a:lvl1pPr>
-          </a:lstStyle>
-          <a:p>
-            <a:fld id="{CE5E9CC1-C706-0F49-92D6-E571CC5EEA8F}" type="slidenum">
-              <a:rPr lang="en-US"/>
-              <a:t>‹#›</a:t>
-            </a:fld>
-            <a:endParaRPr lang="en-US"/>
-          </a:p>
-        </p:txBody>
-      </p:sp>
     </p:spTree>
     <p:extLst>
       <p:ext uri="{BB962C8B-B14F-4D97-AF65-F5344CB8AC3E}">
-        <p14:creationId xmlns:p14="http://schemas.microsoft.com/office/powerpoint/2010/main" val="1024086991"/>
+        <p14:creationId xmlns:p14="http://schemas.microsoft.com/office/powerpoint/2010/main" val="2127480336"/>
       </p:ext>
     </p:extLst>
   </p:cSld>
@@ -529,7 +310,6 @@
               <a:rPr lang="en-US" dirty="0"/>
               <a:t>歡迎加入。今天這份簡報的目標只有一個:讓你三十分鐘內看懂 DMP Flowable ETL 整條管線在做什麼,以及怎麼動手驗證。重點放兩個地方:第一是 L5 任務完成率的計算邏輯,這是整個系統最容易誤解、最常被問的部分;第二是四個 Hands-on Task,跑完這四個你就能獨立交接日常維運。後面所有例子都會用 2025 年 12 月 25 到 31 號這一週,WJ2 廠 NBU 工廠 E5 產線的真實資料來說明,這樣比較有畫面。</a:t>
             </a:r>
-            <a:endParaRPr lang="en-US" dirty="0"/>
           </a:p>
         </p:txBody>
       </p:sp>
@@ -617,7 +397,6 @@
               <a:rPr lang="en-US" dirty="0"/>
               <a:t>Bronze 進來之後,我們要把它變成有業務語意的事實表,這是 Silver 跟 Gold 兩層在做的事。三張投影片串起來:Silver 怎麼大 JOIN 出寬表、寬表的五階維度是怎麼被貼上的、Gold 又是怎麼把 task_id 壓成 Bitmap 換查詢速度。這段是整個 ETL 系統業務邏輯最濃縮的地方。</a:t>
             </a:r>
-            <a:endParaRPr lang="en-US" dirty="0"/>
           </a:p>
         </p:txBody>
       </p:sp>
@@ -705,7 +484,6 @@
               <a:rPr lang="en-US" dirty="0"/>
               <a:t>Silver 層是整個系統運算的核心,做兩件事。第一件是 backfill_pivot.sql 把 Flowable 的 Key-Value 業務變數攤平。Flowable 設計上每個變數一行,例如 plant、lineName、moNumber 各佔一筆,我們用 argMaxIf 取 REV 最大的那筆攤成欄位。第二件事是 backfill_silver.sql 的大 JOIN,把任務、流程、人員、變數、MDM 五張表 JOIN 成 mv_fact_task_vx 這張事實寬表。所有 KPI 的計算都從這張表出發,你只要記得這一張就好。然後 backfill_exclusion.sql 做排除旗標的二次修正,主要修 autoComplete 變數的邏輯漏洞。</a:t>
             </a:r>
-            <a:endParaRPr lang="en-US" dirty="0"/>
           </a:p>
         </p:txBody>
       </p:sp>
@@ -793,7 +571,6 @@
               <a:rPr lang="en-US" dirty="0"/>
               <a:t>這張投影片在講「五階維度」── 你可以想成是任務的座標系。每筆任務進到 Silver 表,都會被貼上五個標籤:作業類型、區域、廠、工廠、產線。為什麼這五個重要?因為後面所有 KPI 切片、Gold 層的 Bitmap 預聚合、儀表板下鑽,都是靠這五個維度組合在切資料,Golden Number 的 CNE/WJ2/NBU/E5 也就是這個座標系下的一個切片。重點是這些標籤怎麼來:vx_type 比較單純,從 TASK_DEF_KEY_ 前綴判定 V1/V2/V3。剩下四個 region/plant/factory/line 比較有故事 ── 我們先讀業務變數 varinst_plant 那一類,因為業務系統的值最準。如果業務變數是空的,才退回去用人員的組織關係從 MDM 主檔推導。兩條路都失敗的會落到 UNKNOWN 分桶,讓你發現資料異常。維護時記得這個優先順序:業務變數優先、MDM 是退路,不要倒過來。</a:t>
             </a:r>
-            <a:endParaRPr lang="en-US" dirty="0"/>
           </a:p>
         </p:txBody>
       </p:sp>
@@ -881,7 +658,6 @@
               <a:rPr lang="en-US" dirty="0"/>
               <a:t>Gold 層存的不是明細,而是已經預聚合過的 Bitmap 快照。每天、每個五階維度組合各存一張 Bitmap,Bitmap 裡裝的是 task_id。為什麼要這樣設計?因為去重計數在大資料下非常貴,Bitmap 讓我們可以做毫秒級的 distinct count,而且支援集合運算。三張 Gold 表分工是這樣:milestone_phys 存 TODO/DOING/DONE 的 Bitmap,acc_phys 存 7 天滾動的 WIP 負荷量,task_completion_phys 是兩者 LEFT JOIN 後的最終匯總,前端只讀這張。</a:t>
             </a:r>
-            <a:endParaRPr lang="en-US" dirty="0"/>
           </a:p>
         </p:txBody>
       </p:sp>
@@ -969,7 +745,6 @@
               <a:rPr lang="en-US" dirty="0"/>
               <a:t>重頭戲來了。L5 任務完成率是業務最常問、也是最容易誤解的指標。接下來四張投影片串起一個完整故事:Cohort 是計算靈魂、三種結算粒度有三組不同分母、Bitmap 怎麼跨日聯集去重、Cube.js 怎麼在查詢時動態組裝。這四個概念聽完,你才算真正掌握 L5 KPI。</a:t>
             </a:r>
-            <a:endParaRPr lang="en-US" dirty="0"/>
           </a:p>
         </p:txBody>
       </p:sp>
@@ -1057,7 +832,6 @@
               <a:rPr lang="en-US" dirty="0"/>
               <a:t>現在進入今天最關鍵的部分:L5 完成率的設計哲學,核心是 Cohort 也就是梯次的概念。一句話講完:一個任務屬於哪個 Cohort,是看它在哪一天、哪一週、哪一個月開單,不是看它什麼時候完成。所以日結算、週結算、月結算其實在算三組完全不同的 Cohort。為什麼這樣設計?因為產線經理要回答的問題是「這週開出來的單,到週末有沒有結清」,而不是「這週完成了幾個單」。前者是計畫達成率,後者是產能利用率,意義完全不同。一個 Cohort 內 todo + doing + done 永遠等於 total,沒有任何單會重複計算或遺漏,這是這個設計最重要的不變式。</a:t>
             </a:r>
-            <a:endParaRPr lang="en-US" dirty="0"/>
           </a:p>
         </p:txBody>
       </p:sp>
@@ -1145,7 +919,6 @@
               <a:rPr lang="en-US" dirty="0"/>
               <a:t>三種結算粒度看起來像但分母不一樣。Day 粒度的 ACC Rate 分母是過去 7 天的開單總量,我們稱為 acc_total_task,因為單天樣本太小,用 7 天滾動才能反映真實的 WIP 壓力。Week 和 Month 的分母直接用該週期的 total,因為週期本身夠長,直接看計畫達成率最直觀。我們用 12 月 22 到 28 號 W52 這一週舉例:總共開了 583 個任務,週末 12/28 結算時 537 個已 done,29 個 todo、17 個 doing,落後率 7.9%。再對照 W49 的落後率是 0%,因為查詢時間 12/31 已經遠超過 W49 結束,所有任務都到達最終態,done 等於 total。這就是 Cohort 邏輯帶來的時間感。</a:t>
             </a:r>
-            <a:endParaRPr lang="en-US" dirty="0"/>
           </a:p>
         </p:txBody>
       </p:sp>
@@ -1233,7 +1006,6 @@
               <a:rPr lang="en-US" dirty="0"/>
               <a:t>這一頁的觀念其實很單純,我用一個比喻你會比較有感覺。想像我們每天會拍一張團體照,照片裡是當天還在進行中的任務,每張照片就是一張 Bitmap。問題來了 ── 某個任務從禮拜一忙到禮拜三才結束,所以這三天的照片裡都有他的臉。如果你問「這一週有幾個進行中的任務」,然後把三張照片裡的人頭數直接加起來,你會發現同一個人被算了三次,這顯然不對。正確的做法是把三張照片疊在一起,重複的臉只算一次,這就叫聯集去重,程式裡的 groupBitmapMergeState 在做的就是這件事。那為什麼要這麼搞工?因為傳統 count distinct 在幾千萬筆資料下要跑好幾秒,但 Bitmap 是用位元壓縮過的,聯集起來只要幾毫秒,差了好幾個數量級。所以我們花一次性的力氣把 task_id 壓成 Bitmap,換來的是日後每次查詢都飛快。</a:t>
             </a:r>
-            <a:endParaRPr lang="en-US" dirty="0"/>
           </a:p>
         </p:txBody>
       </p:sp>
@@ -1321,7 +1093,6 @@
               <a:rPr lang="en-US" dirty="0"/>
               <a:t>Cube.js 在我們系統裡扮演的是「語意層」的角色 — 它的工作不是計算,而是把 Gold 表的每日 Bitmap 在查詢時動態組裝成 Day、Week、Month 三種粒度。為什麼要這樣設計?因為如果我們在 Gold 預先存好週、月的聚合結果,當業務臨時想看「滾動 28 天」或「自然週對齊」這種彈性視窗時就會卡死。Cube.js 把這個彈性下放給查詢端,讓 Gold 只負責存最原子的每日 Bitmap。完整查詢流程是這樣:前端打 GraphQL 或 REST 進來 → Cube.js 根據 timeDimension 翻譯成 ClickHouse SQL → groupBitmapMergeState 完成跨日聯集 → 結果回到儀表板。記住對外契約這件事:cube_l5_task_periodic.js 裡的 measures 跟 dimensions 名稱不能亂改,前端是用名稱在綁定的。</a:t>
             </a:r>
-            <a:endParaRPr lang="en-US" dirty="0"/>
           </a:p>
         </p:txBody>
       </p:sp>
@@ -1409,7 +1180,6 @@
               <a:rPr lang="en-US" dirty="0"/>
               <a:t>Section 4 講完原理,Section 5 回到動手實作。你會學到怎麼真正跑 ETL、開發工作流的核心準則 (SQL 改邏輯、Python 跑任務)、改完邏輯後對 Golden Number 驗收、以及在 ClickHouse 原生終端機查 Bitmap 的實用技巧。</a:t>
             </a:r>
-            <a:endParaRPr lang="en-US" dirty="0"/>
           </a:p>
         </p:txBody>
       </p:sp>
@@ -1497,7 +1267,6 @@
               <a:rPr lang="en-US" dirty="0"/>
               <a:t>先看整條管線的長相。資料從 MSSQL 兩個來源系統進來,APP_SRV_BPM 是 Flowable 流程引擎,APP_SRV_COMMON 是人員跟組織主檔。但在資料進來之前,要先跑 Step 1 的 setup_schema.py 把 Bronze 、 Silver 、 Gold 三層的空表建起來 — 這是所有後續動作的前置條件,不先建表,資料沒有地方可以落。Step 2 才把原始資料一比一複製到 Bronze,完全不加工,這是為了讓 Silver 層出問題時可以隨時溯源。Step 3 才是真正的運算,分成 Silver 跟 Gold 兩層。Silver 是大寬表,Gold 是預聚合的 KPI 物理表,前端 Cube.js 只讀 Gold。記住一個原則:Bronze 搬資料、Silver 做 JOIN、Gold 做聚合,職責切得很乾淨。</a:t>
             </a:r>
-            <a:endParaRPr lang="en-US" dirty="0"/>
           </a:p>
         </p:txBody>
       </p:sp>
@@ -1585,7 +1354,6 @@
               <a:rPr lang="en-US" dirty="0"/>
               <a:t>Task 3 是日常會用最多的指令,執行 Bronze 到 Gold 的轉換。初次建置用 --backfill 跑完整時間區間,日常維運直接呼叫 daily_etl_wrapper.sh,它會自己只重算最近 7 天。--low-ram 一定要加,沒加很容易踩到 ClickHouse 的 memory limit。輸出每段會印 Processing 哪張表、時間區間、執行秒數。如果跑到一半 OOM,系統會自動把時間窗口切半重試,看到 retry 不用緊張。最後要看到 All calculation phases completed successfully 才算過。</a:t>
             </a:r>
-            <a:endParaRPr lang="en-US" dirty="0"/>
           </a:p>
         </p:txBody>
       </p:sp>
@@ -1673,7 +1441,6 @@
               <a:rPr lang="en-US" dirty="0"/>
               <a:t>這一頁講的是新人最容易卡關的一個觀念:我們系統的設計是「邏輯與執行分離」,英文叫模板驅動 (template-driven)。意思是 SQL 不會自己跑,你改完 SQL 必須透過 Python 程式發動。為什麼這樣設計?因為 Python 會幫你做三件事:第一,把 {start_ts} 之類的時間佔位符換成真實日期;第二,處理 OOM 自動切半;第三,記錄 etl_checkpoint。如果你跳過 Python,直接在 DBeaver 改 SQL 寫死邏輯到資料庫,下次自動化排程一跑,你的修改會被覆蓋,白搞一場。所以核心準則只有一句:先修邏輯 SQL,再跑任務 Python。DBeaver 是手動測試用的 ── 模板裡有 {start_ts},DBeaver 跑不了,你要手動換成具體日期再跑。流程記住三步:改 SQL → 跑 --daily → 對 Golden Number 驗收。</a:t>
             </a:r>
-            <a:endParaRPr lang="en-US" dirty="0"/>
           </a:p>
         </p:txBody>
       </p:sp>
@@ -1761,7 +1528,6 @@
               <a:rPr lang="en-US" dirty="0"/>
               <a:t>Task 4 是驗收。改過任何邏輯之後,你都要跑 audit_done_details.py 跟 check_gold.py 比對基準數字。我們維護一份固定的 Golden Number,範例就是右邊這張表:CNE/WJ2/NBU/E5 在 12/25 到 12/31 七天的 Daily、Weekly、Monthly 三個粒度,每個格子的數字都是經過業務確認過的。你改完 SQL 重跑之後,這些數字必須一個不差。如果對不上要先想:是你改的邏輯動到 Cohort 邊界?還是漏了某個排除旗標?還是 Bitmap 聯集寫錯?九成的 bug 都在這三類。</a:t>
             </a:r>
-            <a:endParaRPr lang="en-US" dirty="0"/>
           </a:p>
         </p:txBody>
       </p:sp>
@@ -1849,7 +1615,6 @@
               <a:rPr lang="en-US" dirty="0"/>
               <a:t>這是一個非常實用的小技巧,你日常 debug 一定會用到。我們的 Bitmap 在 ClickHouse 底層是用 RoaringBitmap 壓縮存的,如果你直接打 SELECT todo_daily 想看內容,會跳出來 ClickHouseRoaring64NavigableMap 這種完全看不懂的物件 ── 不是壞了,只是沒有展開。記三個函數就夠用:第一個 bitmapCardinality 看數量,回傳整數,是最常用的;第二個 bitmapToArray 看內容,把 Bitmap 攤開成 task_id 陣列,適合對特定任務做明細稽核;第三個是進階,bitmapCardinality 包 groupBitmapMergeState,搭配 GROUP BY 用,可以把多天的 Bitmap 聯集去重後再算數,這就是 Cube.js 在背後幫我們做的事。右邊那段 SQL 是個能直接複製貼上的實戰範例,跑出來的數字應該要跟 Golden Number 表完全對得上。萬一對不上,先檢查你的 WHERE 條件是不是真的鎖到 CNE/WJ2/NBU/E5 這個切片。</a:t>
             </a:r>
-            <a:endParaRPr lang="en-US" dirty="0"/>
           </a:p>
         </p:txBody>
       </p:sp>
@@ -1937,7 +1702,6 @@
               <a:rPr lang="en-US" dirty="0"/>
               <a:t>最後是附錄跟總結。術語表 + FAQ 是你日常 debug 的速查表,看到不熟的語法翻一下就好。最後總結三件事:職責分層、Cohort 是 L5 靈魂、Golden Number 是事實基準。Q&amp;A 隨時歡迎。</a:t>
             </a:r>
-            <a:endParaRPr lang="en-US" dirty="0"/>
           </a:p>
         </p:txBody>
       </p:sp>
@@ -2025,7 +1789,6 @@
               <a:rPr lang="en-US" dirty="0"/>
               <a:t>這頁是參考附錄,簡報結束你不用記它,但出現以下三種情況時記得翻回來。第一,你看到查出來的筆數變多 ── 多半是 ClickHouse 還在背景合併,加 FINAL 或用 argMax 取最新版。第二,你改完 SQL 跑 execute_etl 但數字沒變 ── 八成是 checkpoint 已經是 SUCCESS 被跳過,加 --reset 強迫重跑。第三,出 OOM ── 加 --low-ram 或縮短 --step-days,系統也會自己切半重試。Glossary 那邊列了五個你看 SQL 一定會遇到的術語:ReplacingMergeTree、argMax、groupBitmapState、ODBC Table Function、FINAL,看到不懂的回來查一下就好。這頁的目的就是讓你不要因為一個語法卡住而停下來,把卡關的工夫拿去解業務問題才對。</a:t>
             </a:r>
-            <a:endParaRPr lang="en-US" dirty="0"/>
           </a:p>
         </p:txBody>
       </p:sp>
@@ -2113,7 +1876,6 @@
               <a:rPr lang="en-US" dirty="0"/>
               <a:t>總結三件事。第一,記住職責分層:Bronze 搬、Silver JOIN、Gold 聚合,你維護的時候絕大多數時間只會碰 Silver 跟 Gold 的 DML。第二,Cohort 是 L5 完成率的靈魂,看到任何完成率報表先問自己分母是用哪個 Cohort 的 total。第三,改完邏輯一定要對 Golden Number,這是我們唯一的事實基準。後面 Q&amp;A 時間,任何不清楚的地方都歡迎問,特別是 Bitmap 聯集跟排除旗標這兩個地方最容易踩坑。</a:t>
             </a:r>
-            <a:endParaRPr lang="en-US" dirty="0"/>
           </a:p>
         </p:txBody>
       </p:sp>
@@ -2201,7 +1963,6 @@
               <a:rPr lang="en-US" dirty="0"/>
               <a:t>這張投影片是整條資料流向的完整地圖,你可以把它當成後面所有討論的索引。從上往下看一共會經過七個檢查點。第一站是 MSSQL 兩個來源系統,APP_SRV_BPM 跟 APP_SRV_COMMON,負責提供業務資料跟人員主檔。第二站是 Bronze,Step 2 的 sync_unified_odbc.py 把資料一比一搬進來,主檔全量、流水帳增量。第三站是 silver.mv_varinst_pivoted,執行的是 backfill_pivot.sql,把 Flowable 的 Key-Value 變數攤平成寬表。第四站是 silver.mv_fact_task_vx,這是整個系統的核心事實表,所有 KPI 都從這裡長出來,由 backfill_silver 大 JOIN + backfill_exclusion 二次修正排除旗標完成。第五站是 Gold 層三張物理表 milestone、acc、completion,分別由 [D][E][F] 三支 SQL 產出。第六站 Cube.js 在查詢時把 Gold 的每日 Bitmap 動態組裝成 Day、Week、Month 三種粒度。最後第七站才是前端儀表板。記住一句話:每一條箭頭代表一支腳本或一段 SQL,維護出問題時,先定位是哪條箭頭斷掉,而不是亂改表結構。</a:t>
             </a:r>
-            <a:endParaRPr lang="en-US" dirty="0"/>
           </a:p>
         </p:txBody>
       </p:sp>
@@ -2289,7 +2050,6 @@
               <a:rPr lang="en-US" dirty="0"/>
               <a:t>專案目錄結構是另一張要熟記的圖。我們把職責切得非常乾淨,大致分三大塊。第一塊 scripts/etl 是 Python 調度層,你日常 90% 的指令都在這個資料夾,後面四個 Task 分別對應裡面四支腳本。第二塊 sql/etl 又再切成 schema 和 dml 兩個子資料夾 — schema 只放欄位 DDL,只有 setup_schema.py 會去讀;dml 才是業務邏輯所在地,只有 execute_etl.py 會去讀,這也是我們維護時最常碰的地方。第三塊 cube/model/cubes 是 Cube.js 的語意層,獨立服務,只讀 Gold 表。每張 config yaml 對應一支 script 讀,這個對應關係右側的小表寫得很清楚。記住:要改邏輯就去 dml,要改欄位才去 schema,兩邊不要混。</a:t>
             </a:r>
-            <a:endParaRPr lang="en-US" dirty="0"/>
           </a:p>
         </p:txBody>
       </p:sp>
@@ -2377,7 +2137,6 @@
               <a:rPr lang="en-US" dirty="0"/>
               <a:t>好,系統觀念過完了,接下來進入第一個動手實作區塊。你會學到怎麼把 MSSQL 的原始資料搬到 ClickHouse,以及背後三個穩定性機制 ── 顯式 DDL 代理表、Watermark、適應性分切。先看右邊那張五個核心步驟的索引卡,當作整段 hands-on 的地圖。</a:t>
             </a:r>
-            <a:endParaRPr lang="en-US" dirty="0"/>
           </a:p>
         </p:txBody>
       </p:sp>
@@ -2465,7 +2224,6 @@
               <a:rPr lang="en-US" dirty="0"/>
               <a:t>這張是整個教學的索引卡,五條指令照順序跑下來,你就能在 ClickHouse 看到完整 KPI 資料。第一步 setup_schema.py 建空表 ── 只有第一次或 schema 改版才跑。第二步 sync_unified_odbc.py 把 MSSQL 資料一比一搬到 Bronze,主檔全量、流水帳增量。第三步是重頭戲 execute_etl.py --backfill --low-ram,跑完 pivot、大 JOIN、排除旗標、Bitmap 聚合、ACC 7 日、最終匯總六道 SQL,Silver 跟 Gold 一次到位 ── low-ram 記得一定要加,沒加很容易踩 OOM。第四步 --status 是快速 sanity check,看各層筆數對不對。第五步 audit_done_details.py 拿一個具體日期 (例如 2025-12-31) 出來看明細,可以直接給業務對帳。卡關時記住兩個招式:--reset 強迫重算、查 etl_checkpoint 看哪段失敗。</a:t>
             </a:r>
-            <a:endParaRPr lang="en-US" dirty="0"/>
           </a:p>
         </p:txBody>
       </p:sp>
@@ -2553,7 +2311,6 @@
               <a:rPr lang="en-US" dirty="0"/>
               <a:t>Task 1 是環境準備。你拿到機器第一件事是確認三個連線:ClickHouse 主庫、MSSQL 來源、ODBC 中介層。預設帳密放在環境變數,不要寫死在程式裡。連線通了之後執行 setup_schema.py,它會讀 infra_config.yaml 依序建 bronze、silver、gold 三層的空表。注意這一步只有第一次建置或 schema 改版才會跑,平常不要碰。如果你在 console 看到一堆 CREATE TABLE IF NOT EXISTS OK,沒有 Error,就算過關。</a:t>
             </a:r>
-            <a:endParaRPr lang="en-US" dirty="0"/>
           </a:p>
         </p:txBody>
       </p:sp>
@@ -2641,7 +2398,6 @@
               <a:rPr lang="en-US" dirty="0"/>
               <a:t>Task 2 把 MSSQL 的原始資料搬到 Bronze。指令很單純,sync_unified_odbc.py --table all。重點是它分兩種同步模式:主檔像人員、組織是全量覆蓋,每次跑都重來;Flowable 的流水帳像任務、變數是增量追加,靠 Watermark 紀錄上次跑到哪。如果你只想測試連線通不通,可以先跑 --table hr_employee 看單張表。輸出看到每張表都印 Synced X rows 就 OK。要強調的是這一步純搬資料、不做任何運算,所以 Bronze 的欄位幾乎就是 MSSQL 原貌。</a:t>
             </a:r>
-            <a:endParaRPr lang="en-US" dirty="0"/>
           </a:p>
         </p:txBody>
       </p:sp>
@@ -2729,7 +2485,6 @@
               <a:rPr lang="en-US" dirty="0"/>
               <a:t>這一頁專門講 Bronze 同步背後的三個穩定性機制,你可能會問:為什麼不直接用 ClickHouse 的 odbc 函數,要這麼麻煩?原因是原生 odbc 偵測 MSSQL 欄位時,遇到 varchar(max) 或 xml 這類大物件,要不就是直接報錯,要不就是在來源端鎖表把整個 MSSQL 卡死,DBA 會殺人。所以我們改用顯式 DDL 代理表 ── 先在 ClickHouse 建一張預定義欄位的 temp_odbc 表,再用 INSERT SELECT 把資料從 ODBC 拉進來,完全避開自動推斷。第二個是 Watermark 增量,每張流水帳的 ModifyDate 上限記在 bronze._sync_watermark 表裡,下次同步只拉新的。第三個是適應性分切,如果一段時間範圍跑 OOM,系統會自動切半重試,不需要人工介入。最常用的修復技巧是:某張表資料怪怪的,DELETE 它在 _sync_watermark 的紀錄,重跑 sync 就會從頭拉,這個招式記下來,以後你會用到。</a:t>
             </a:r>
-            <a:endParaRPr lang="en-US" dirty="0"/>
           </a:p>
         </p:txBody>
       </p:sp>
@@ -2791,6 +2546,42 @@
           <a:chExt cx="0" cy="0"/>
         </a:xfrm>
       </p:grpSpPr>
+      <p:pic>
+        <p:nvPicPr>
+          <p:cNvPr id="2" name="圖片 1">
+            <a:extLst>
+              <a:ext uri="{FF2B5EF4-FFF2-40B4-BE49-F238E27FC236}">
+                <a16:creationId xmlns:a16="http://schemas.microsoft.com/office/drawing/2014/main" id="{730A6D09-8086-3367-3961-3338CB770631}"/>
+              </a:ext>
+            </a:extLst>
+          </p:cNvPr>
+          <p:cNvPicPr>
+            <a:picLocks noChangeAspect="1"/>
+          </p:cNvPicPr>
+          <p:nvPr userDrawn="1"/>
+        </p:nvPicPr>
+        <p:blipFill>
+          <a:blip r:embed="rId2" cstate="print">
+            <a:extLst>
+              <a:ext uri="{28A0092B-C50C-407E-A947-70E740481C1C}">
+                <a14:useLocalDpi xmlns:a14="http://schemas.microsoft.com/office/drawing/2010/main" val="0"/>
+              </a:ext>
+            </a:extLst>
+          </a:blip>
+          <a:stretch>
+            <a:fillRect/>
+          </a:stretch>
+        </p:blipFill>
+        <p:spPr>
+          <a:xfrm>
+            <a:off x="16920000" y="9666655"/>
+            <a:ext cx="1368000" cy="620345"/>
+          </a:xfrm>
+          <a:prstGeom prst="rect">
+            <a:avLst/>
+          </a:prstGeom>
+        </p:spPr>
+      </p:pic>
     </p:spTree>
   </p:cSld>
   <p:clrMapOvr>
@@ -2802,6 +2593,11 @@
 <file path=ppt/slideMasters/slideMaster1.xml><?xml version="1.0" encoding="utf-8"?>
 <p:sldMaster xmlns:a="http://schemas.openxmlformats.org/drawingml/2006/main" xmlns:r="http://schemas.openxmlformats.org/officeDocument/2006/relationships" xmlns:p="http://schemas.openxmlformats.org/presentationml/2006/main">
   <p:cSld>
+    <p:bg>
+      <p:bgRef idx="1001">
+        <a:schemeClr val="bg1"/>
+      </p:bgRef>
+    </p:bg>
     <p:spTree>
       <p:nvGrpSpPr>
         <p:cNvPr id="1" name=""/>
@@ -2816,6 +2612,42 @@
           <a:chExt cx="0" cy="0"/>
         </a:xfrm>
       </p:grpSpPr>
+      <p:pic>
+        <p:nvPicPr>
+          <p:cNvPr id="2" name="圖片 1">
+            <a:extLst>
+              <a:ext uri="{FF2B5EF4-FFF2-40B4-BE49-F238E27FC236}">
+                <a16:creationId xmlns:a16="http://schemas.microsoft.com/office/drawing/2014/main" id="{4FA148EA-08D7-8F59-EA25-4E92C54317E3}"/>
+              </a:ext>
+            </a:extLst>
+          </p:cNvPr>
+          <p:cNvPicPr>
+            <a:picLocks noChangeAspect="1"/>
+          </p:cNvPicPr>
+          <p:nvPr userDrawn="1"/>
+        </p:nvPicPr>
+        <p:blipFill>
+          <a:blip r:embed="rId3" cstate="print">
+            <a:extLst>
+              <a:ext uri="{28A0092B-C50C-407E-A947-70E740481C1C}">
+                <a14:useLocalDpi xmlns:a14="http://schemas.microsoft.com/office/drawing/2010/main" val="0"/>
+              </a:ext>
+            </a:extLst>
+          </a:blip>
+          <a:stretch>
+            <a:fillRect/>
+          </a:stretch>
+        </p:blipFill>
+        <p:spPr>
+          <a:xfrm>
+            <a:off x="16691103" y="9558371"/>
+            <a:ext cx="1368000" cy="620345"/>
+          </a:xfrm>
+          <a:prstGeom prst="rect">
+            <a:avLst/>
+          </a:prstGeom>
+        </p:spPr>
+      </p:pic>
     </p:spTree>
   </p:cSld>
   <p:clrMap bg1="lt1" tx1="dk1" bg2="lt2" tx2="dk2" accent1="accent1" accent2="accent2" accent3="accent3" accent4="accent4" accent5="accent5" accent6="accent6" hlink="hlink" folHlink="folHlink"/>
@@ -3095,14 +2927,14 @@
       </p:grpSpPr>
       <p:pic>
         <p:nvPicPr>
-          <p:cNvPr id="2" name="Image 0" descr="preencoded.png">    </p:cNvPr>
+          <p:cNvPr id="2" name="Image 0" descr="preencoded.png"/>
           <p:cNvPicPr>
             <a:picLocks noChangeAspect="1"/>
           </p:cNvPicPr>
           <p:nvPr/>
         </p:nvPicPr>
         <p:blipFill>
-          <a:blip r:embed="rId1"/>
+          <a:blip r:embed="rId3"/>
           <a:stretch>
             <a:fillRect/>
           </a:stretch>
@@ -3111,6 +2943,213 @@
           <a:xfrm>
             <a:off x="0" y="0"/>
             <a:ext cx="18288000" cy="10287000"/>
+          </a:xfrm>
+          <a:prstGeom prst="rect">
+            <a:avLst/>
+          </a:prstGeom>
+        </p:spPr>
+      </p:pic>
+      <p:sp>
+        <p:nvSpPr>
+          <p:cNvPr id="4" name="頁尾版面配置區 3">
+            <a:extLst>
+              <a:ext uri="{FF2B5EF4-FFF2-40B4-BE49-F238E27FC236}">
+                <a16:creationId xmlns:a16="http://schemas.microsoft.com/office/drawing/2014/main" id="{2FF80A83-1247-AEB7-13CB-4E16EE52595A}"/>
+              </a:ext>
+            </a:extLst>
+          </p:cNvPr>
+          <p:cNvSpPr txBox="1">
+            <a:spLocks/>
+          </p:cNvSpPr>
+          <p:nvPr/>
+        </p:nvSpPr>
+        <p:spPr>
+          <a:xfrm>
+            <a:off x="15138219" y="9216418"/>
+            <a:ext cx="5707316" cy="218356"/>
+          </a:xfrm>
+          <a:prstGeom prst="rect">
+            <a:avLst/>
+          </a:prstGeom>
+        </p:spPr>
+        <p:txBody>
+          <a:bodyPr/>
+          <a:lstStyle>
+            <a:lvl1pPr marL="0" algn="l" defTabSz="914400" rtl="0" eaLnBrk="1" latinLnBrk="0" hangingPunct="1">
+              <a:defRPr sz="1800" kern="1200">
+                <a:solidFill>
+                  <a:schemeClr val="tx1"/>
+                </a:solidFill>
+                <a:latin typeface="+mn-lt"/>
+                <a:ea typeface="+mn-ea"/>
+                <a:cs typeface="+mn-cs"/>
+              </a:defRPr>
+            </a:lvl1pPr>
+            <a:lvl2pPr marL="457200" algn="l" defTabSz="914400" rtl="0" eaLnBrk="1" latinLnBrk="0" hangingPunct="1">
+              <a:defRPr sz="1800" kern="1200">
+                <a:solidFill>
+                  <a:schemeClr val="tx1"/>
+                </a:solidFill>
+                <a:latin typeface="+mn-lt"/>
+                <a:ea typeface="+mn-ea"/>
+                <a:cs typeface="+mn-cs"/>
+              </a:defRPr>
+            </a:lvl2pPr>
+            <a:lvl3pPr marL="914400" algn="l" defTabSz="914400" rtl="0" eaLnBrk="1" latinLnBrk="0" hangingPunct="1">
+              <a:defRPr sz="1800" kern="1200">
+                <a:solidFill>
+                  <a:schemeClr val="tx1"/>
+                </a:solidFill>
+                <a:latin typeface="+mn-lt"/>
+                <a:ea typeface="+mn-ea"/>
+                <a:cs typeface="+mn-cs"/>
+              </a:defRPr>
+            </a:lvl3pPr>
+            <a:lvl4pPr marL="1371600" algn="l" defTabSz="914400" rtl="0" eaLnBrk="1" latinLnBrk="0" hangingPunct="1">
+              <a:defRPr sz="1800" kern="1200">
+                <a:solidFill>
+                  <a:schemeClr val="tx1"/>
+                </a:solidFill>
+                <a:latin typeface="+mn-lt"/>
+                <a:ea typeface="+mn-ea"/>
+                <a:cs typeface="+mn-cs"/>
+              </a:defRPr>
+            </a:lvl4pPr>
+            <a:lvl5pPr marL="1828800" algn="l" defTabSz="914400" rtl="0" eaLnBrk="1" latinLnBrk="0" hangingPunct="1">
+              <a:defRPr sz="1800" kern="1200">
+                <a:solidFill>
+                  <a:schemeClr val="tx1"/>
+                </a:solidFill>
+                <a:latin typeface="+mn-lt"/>
+                <a:ea typeface="+mn-ea"/>
+                <a:cs typeface="+mn-cs"/>
+              </a:defRPr>
+            </a:lvl5pPr>
+            <a:lvl6pPr marL="2286000" algn="l" defTabSz="914400" rtl="0" eaLnBrk="1" latinLnBrk="0" hangingPunct="1">
+              <a:defRPr sz="1800" kern="1200">
+                <a:solidFill>
+                  <a:schemeClr val="tx1"/>
+                </a:solidFill>
+                <a:latin typeface="+mn-lt"/>
+                <a:ea typeface="+mn-ea"/>
+                <a:cs typeface="+mn-cs"/>
+              </a:defRPr>
+            </a:lvl6pPr>
+            <a:lvl7pPr marL="2743200" algn="l" defTabSz="914400" rtl="0" eaLnBrk="1" latinLnBrk="0" hangingPunct="1">
+              <a:defRPr sz="1800" kern="1200">
+                <a:solidFill>
+                  <a:schemeClr val="tx1"/>
+                </a:solidFill>
+                <a:latin typeface="+mn-lt"/>
+                <a:ea typeface="+mn-ea"/>
+                <a:cs typeface="+mn-cs"/>
+              </a:defRPr>
+            </a:lvl7pPr>
+            <a:lvl8pPr marL="3200400" algn="l" defTabSz="914400" rtl="0" eaLnBrk="1" latinLnBrk="0" hangingPunct="1">
+              <a:defRPr sz="1800" kern="1200">
+                <a:solidFill>
+                  <a:schemeClr val="tx1"/>
+                </a:solidFill>
+                <a:latin typeface="+mn-lt"/>
+                <a:ea typeface="+mn-ea"/>
+                <a:cs typeface="+mn-cs"/>
+              </a:defRPr>
+            </a:lvl8pPr>
+            <a:lvl9pPr marL="3657600" algn="l" defTabSz="914400" rtl="0" eaLnBrk="1" latinLnBrk="0" hangingPunct="1">
+              <a:defRPr sz="1800" kern="1200">
+                <a:solidFill>
+                  <a:schemeClr val="tx1"/>
+                </a:solidFill>
+                <a:latin typeface="+mn-lt"/>
+                <a:ea typeface="+mn-ea"/>
+                <a:cs typeface="+mn-cs"/>
+              </a:defRPr>
+            </a:lvl9pPr>
+          </a:lstStyle>
+          <a:p>
+            <a:r>
+              <a:rPr lang="en-US" altLang="zh-TW" dirty="0">
+                <a:solidFill>
+                  <a:schemeClr val="bg2">
+                    <a:lumMod val="75000"/>
+                  </a:schemeClr>
+                </a:solidFill>
+              </a:rPr>
+              <a:t>Albee</a:t>
+            </a:r>
+            <a:r>
+              <a:rPr lang="zh-TW" altLang="en-US" dirty="0">
+                <a:solidFill>
+                  <a:schemeClr val="bg2">
+                    <a:lumMod val="75000"/>
+                  </a:schemeClr>
+                </a:solidFill>
+              </a:rPr>
+              <a:t>｜</a:t>
+            </a:r>
+            <a:r>
+              <a:rPr lang="en-US" altLang="zh-TW" dirty="0">
+                <a:solidFill>
+                  <a:schemeClr val="bg2">
+                    <a:lumMod val="75000"/>
+                  </a:schemeClr>
+                </a:solidFill>
+              </a:rPr>
+              <a:t>DSM AIT</a:t>
+            </a:r>
+            <a:r>
+              <a:rPr lang="zh-TW" altLang="en-US" dirty="0">
+                <a:solidFill>
+                  <a:schemeClr val="bg2">
+                    <a:lumMod val="75000"/>
+                  </a:schemeClr>
+                </a:solidFill>
+              </a:rPr>
+              <a:t>｜</a:t>
+            </a:r>
+            <a:r>
+              <a:rPr lang="en-US" altLang="zh-TW" dirty="0">
+                <a:solidFill>
+                  <a:schemeClr val="bg2">
+                    <a:lumMod val="75000"/>
+                  </a:schemeClr>
+                </a:solidFill>
+              </a:rPr>
+              <a:t>05/2026</a:t>
+            </a:r>
+          </a:p>
+        </p:txBody>
+      </p:sp>
+      <p:pic>
+        <p:nvPicPr>
+          <p:cNvPr id="5" name="圖片 4">
+            <a:extLst>
+              <a:ext uri="{FF2B5EF4-FFF2-40B4-BE49-F238E27FC236}">
+                <a16:creationId xmlns:a16="http://schemas.microsoft.com/office/drawing/2014/main" id="{E7A3D132-9070-05D7-3CFD-3B474535FB46}"/>
+              </a:ext>
+            </a:extLst>
+          </p:cNvPr>
+          <p:cNvPicPr>
+            <a:picLocks noChangeAspect="1"/>
+          </p:cNvPicPr>
+          <p:nvPr/>
+        </p:nvPicPr>
+        <p:blipFill>
+          <a:blip r:embed="rId4" cstate="print">
+            <a:extLst>
+              <a:ext uri="{28A0092B-C50C-407E-A947-70E740481C1C}">
+                <a14:useLocalDpi xmlns:a14="http://schemas.microsoft.com/office/drawing/2010/main" val="0"/>
+              </a:ext>
+            </a:extLst>
+          </a:blip>
+          <a:stretch>
+            <a:fillRect/>
+          </a:stretch>
+        </p:blipFill>
+        <p:spPr>
+          <a:xfrm>
+            <a:off x="16920000" y="9550714"/>
+            <a:ext cx="1368000" cy="620345"/>
           </a:xfrm>
           <a:prstGeom prst="rect">
             <a:avLst/>
@@ -3144,14 +3183,14 @@
       </p:grpSpPr>
       <p:pic>
         <p:nvPicPr>
-          <p:cNvPr id="2" name="Image 0" descr="preencoded.png">    </p:cNvPr>
+          <p:cNvPr id="2" name="Image 0" descr="preencoded.png"/>
           <p:cNvPicPr>
             <a:picLocks noChangeAspect="1"/>
           </p:cNvPicPr>
           <p:nvPr/>
         </p:nvPicPr>
         <p:blipFill>
-          <a:blip r:embed="rId1"/>
+          <a:blip r:embed="rId3"/>
           <a:stretch>
             <a:fillRect/>
           </a:stretch>
@@ -3160,6 +3199,42 @@
           <a:xfrm>
             <a:off x="0" y="0"/>
             <a:ext cx="18288000" cy="10287000"/>
+          </a:xfrm>
+          <a:prstGeom prst="rect">
+            <a:avLst/>
+          </a:prstGeom>
+        </p:spPr>
+      </p:pic>
+      <p:pic>
+        <p:nvPicPr>
+          <p:cNvPr id="3" name="圖片 2">
+            <a:extLst>
+              <a:ext uri="{FF2B5EF4-FFF2-40B4-BE49-F238E27FC236}">
+                <a16:creationId xmlns:a16="http://schemas.microsoft.com/office/drawing/2014/main" id="{6A2585C6-CD6F-DE0F-E3E1-4ED6313BE81D}"/>
+              </a:ext>
+            </a:extLst>
+          </p:cNvPr>
+          <p:cNvPicPr>
+            <a:picLocks noChangeAspect="1"/>
+          </p:cNvPicPr>
+          <p:nvPr/>
+        </p:nvPicPr>
+        <p:blipFill>
+          <a:blip r:embed="rId4" cstate="print">
+            <a:extLst>
+              <a:ext uri="{28A0092B-C50C-407E-A947-70E740481C1C}">
+                <a14:useLocalDpi xmlns:a14="http://schemas.microsoft.com/office/drawing/2010/main" val="0"/>
+              </a:ext>
+            </a:extLst>
+          </a:blip>
+          <a:stretch>
+            <a:fillRect/>
+          </a:stretch>
+        </p:blipFill>
+        <p:spPr>
+          <a:xfrm>
+            <a:off x="16775324" y="9666655"/>
+            <a:ext cx="1368000" cy="620345"/>
           </a:xfrm>
           <a:prstGeom prst="rect">
             <a:avLst/>
@@ -3193,14 +3268,14 @@
       </p:grpSpPr>
       <p:pic>
         <p:nvPicPr>
-          <p:cNvPr id="2" name="Image 0" descr="preencoded.png">    </p:cNvPr>
+          <p:cNvPr id="2" name="Image 0" descr="preencoded.png"/>
           <p:cNvPicPr>
             <a:picLocks noChangeAspect="1"/>
           </p:cNvPicPr>
           <p:nvPr/>
         </p:nvPicPr>
         <p:blipFill>
-          <a:blip r:embed="rId1"/>
+          <a:blip r:embed="rId3"/>
           <a:stretch>
             <a:fillRect/>
           </a:stretch>
@@ -3209,6 +3284,42 @@
           <a:xfrm>
             <a:off x="0" y="0"/>
             <a:ext cx="18288000" cy="10287000"/>
+          </a:xfrm>
+          <a:prstGeom prst="rect">
+            <a:avLst/>
+          </a:prstGeom>
+        </p:spPr>
+      </p:pic>
+      <p:pic>
+        <p:nvPicPr>
+          <p:cNvPr id="3" name="圖片 2">
+            <a:extLst>
+              <a:ext uri="{FF2B5EF4-FFF2-40B4-BE49-F238E27FC236}">
+                <a16:creationId xmlns:a16="http://schemas.microsoft.com/office/drawing/2014/main" id="{9B1C707F-8ADD-0FE8-4091-5F5118B4DAD2}"/>
+              </a:ext>
+            </a:extLst>
+          </p:cNvPr>
+          <p:cNvPicPr>
+            <a:picLocks noChangeAspect="1"/>
+          </p:cNvPicPr>
+          <p:nvPr/>
+        </p:nvPicPr>
+        <p:blipFill>
+          <a:blip r:embed="rId4" cstate="print">
+            <a:extLst>
+              <a:ext uri="{28A0092B-C50C-407E-A947-70E740481C1C}">
+                <a14:useLocalDpi xmlns:a14="http://schemas.microsoft.com/office/drawing/2010/main" val="0"/>
+              </a:ext>
+            </a:extLst>
+          </a:blip>
+          <a:stretch>
+            <a:fillRect/>
+          </a:stretch>
+        </p:blipFill>
+        <p:spPr>
+          <a:xfrm>
+            <a:off x="16775324" y="9666655"/>
+            <a:ext cx="1368000" cy="620345"/>
           </a:xfrm>
           <a:prstGeom prst="rect">
             <a:avLst/>
@@ -3242,14 +3353,14 @@
       </p:grpSpPr>
       <p:pic>
         <p:nvPicPr>
-          <p:cNvPr id="2" name="Image 0" descr="preencoded.png">    </p:cNvPr>
+          <p:cNvPr id="2" name="Image 0" descr="preencoded.png"/>
           <p:cNvPicPr>
             <a:picLocks noChangeAspect="1"/>
           </p:cNvPicPr>
           <p:nvPr/>
         </p:nvPicPr>
         <p:blipFill>
-          <a:blip r:embed="rId1"/>
+          <a:blip r:embed="rId3"/>
           <a:stretch>
             <a:fillRect/>
           </a:stretch>
@@ -3258,6 +3369,42 @@
           <a:xfrm>
             <a:off x="0" y="0"/>
             <a:ext cx="18288000" cy="10287000"/>
+          </a:xfrm>
+          <a:prstGeom prst="rect">
+            <a:avLst/>
+          </a:prstGeom>
+        </p:spPr>
+      </p:pic>
+      <p:pic>
+        <p:nvPicPr>
+          <p:cNvPr id="3" name="圖片 2">
+            <a:extLst>
+              <a:ext uri="{FF2B5EF4-FFF2-40B4-BE49-F238E27FC236}">
+                <a16:creationId xmlns:a16="http://schemas.microsoft.com/office/drawing/2014/main" id="{7C582A98-C66E-0182-A689-759362277ED6}"/>
+              </a:ext>
+            </a:extLst>
+          </p:cNvPr>
+          <p:cNvPicPr>
+            <a:picLocks noChangeAspect="1"/>
+          </p:cNvPicPr>
+          <p:nvPr/>
+        </p:nvPicPr>
+        <p:blipFill>
+          <a:blip r:embed="rId4" cstate="print">
+            <a:extLst>
+              <a:ext uri="{28A0092B-C50C-407E-A947-70E740481C1C}">
+                <a14:useLocalDpi xmlns:a14="http://schemas.microsoft.com/office/drawing/2010/main" val="0"/>
+              </a:ext>
+            </a:extLst>
+          </a:blip>
+          <a:stretch>
+            <a:fillRect/>
+          </a:stretch>
+        </p:blipFill>
+        <p:spPr>
+          <a:xfrm>
+            <a:off x="16775324" y="9666655"/>
+            <a:ext cx="1368000" cy="620345"/>
           </a:xfrm>
           <a:prstGeom prst="rect">
             <a:avLst/>
@@ -3291,14 +3438,14 @@
       </p:grpSpPr>
       <p:pic>
         <p:nvPicPr>
-          <p:cNvPr id="2" name="Image 0" descr="preencoded.png">    </p:cNvPr>
+          <p:cNvPr id="2" name="Image 0" descr="preencoded.png"/>
           <p:cNvPicPr>
             <a:picLocks noChangeAspect="1"/>
           </p:cNvPicPr>
           <p:nvPr/>
         </p:nvPicPr>
         <p:blipFill>
-          <a:blip r:embed="rId1"/>
+          <a:blip r:embed="rId3"/>
           <a:stretch>
             <a:fillRect/>
           </a:stretch>
@@ -3307,6 +3454,42 @@
           <a:xfrm>
             <a:off x="0" y="0"/>
             <a:ext cx="18288000" cy="10287000"/>
+          </a:xfrm>
+          <a:prstGeom prst="rect">
+            <a:avLst/>
+          </a:prstGeom>
+        </p:spPr>
+      </p:pic>
+      <p:pic>
+        <p:nvPicPr>
+          <p:cNvPr id="3" name="圖片 2">
+            <a:extLst>
+              <a:ext uri="{FF2B5EF4-FFF2-40B4-BE49-F238E27FC236}">
+                <a16:creationId xmlns:a16="http://schemas.microsoft.com/office/drawing/2014/main" id="{84F732D7-35C0-B9B5-040B-D68DE1F2B23E}"/>
+              </a:ext>
+            </a:extLst>
+          </p:cNvPr>
+          <p:cNvPicPr>
+            <a:picLocks noChangeAspect="1"/>
+          </p:cNvPicPr>
+          <p:nvPr/>
+        </p:nvPicPr>
+        <p:blipFill>
+          <a:blip r:embed="rId4" cstate="print">
+            <a:extLst>
+              <a:ext uri="{28A0092B-C50C-407E-A947-70E740481C1C}">
+                <a14:useLocalDpi xmlns:a14="http://schemas.microsoft.com/office/drawing/2010/main" val="0"/>
+              </a:ext>
+            </a:extLst>
+          </a:blip>
+          <a:stretch>
+            <a:fillRect/>
+          </a:stretch>
+        </p:blipFill>
+        <p:spPr>
+          <a:xfrm>
+            <a:off x="16775324" y="9666655"/>
+            <a:ext cx="1368000" cy="620345"/>
           </a:xfrm>
           <a:prstGeom prst="rect">
             <a:avLst/>
@@ -3340,14 +3523,14 @@
       </p:grpSpPr>
       <p:pic>
         <p:nvPicPr>
-          <p:cNvPr id="2" name="Image 0" descr="preencoded.png">    </p:cNvPr>
+          <p:cNvPr id="2" name="Image 0" descr="preencoded.png"/>
           <p:cNvPicPr>
             <a:picLocks noChangeAspect="1"/>
           </p:cNvPicPr>
           <p:nvPr/>
         </p:nvPicPr>
         <p:blipFill>
-          <a:blip r:embed="rId1"/>
+          <a:blip r:embed="rId3"/>
           <a:stretch>
             <a:fillRect/>
           </a:stretch>
@@ -3356,6 +3539,42 @@
           <a:xfrm>
             <a:off x="0" y="0"/>
             <a:ext cx="18288000" cy="10287000"/>
+          </a:xfrm>
+          <a:prstGeom prst="rect">
+            <a:avLst/>
+          </a:prstGeom>
+        </p:spPr>
+      </p:pic>
+      <p:pic>
+        <p:nvPicPr>
+          <p:cNvPr id="3" name="圖片 2">
+            <a:extLst>
+              <a:ext uri="{FF2B5EF4-FFF2-40B4-BE49-F238E27FC236}">
+                <a16:creationId xmlns:a16="http://schemas.microsoft.com/office/drawing/2014/main" id="{CEC72F40-7989-BF2B-2EEA-C960441B557B}"/>
+              </a:ext>
+            </a:extLst>
+          </p:cNvPr>
+          <p:cNvPicPr>
+            <a:picLocks noChangeAspect="1"/>
+          </p:cNvPicPr>
+          <p:nvPr/>
+        </p:nvPicPr>
+        <p:blipFill>
+          <a:blip r:embed="rId4" cstate="print">
+            <a:extLst>
+              <a:ext uri="{28A0092B-C50C-407E-A947-70E740481C1C}">
+                <a14:useLocalDpi xmlns:a14="http://schemas.microsoft.com/office/drawing/2010/main" val="0"/>
+              </a:ext>
+            </a:extLst>
+          </a:blip>
+          <a:stretch>
+            <a:fillRect/>
+          </a:stretch>
+        </p:blipFill>
+        <p:spPr>
+          <a:xfrm>
+            <a:off x="16775324" y="9666655"/>
+            <a:ext cx="1368000" cy="620345"/>
           </a:xfrm>
           <a:prstGeom prst="rect">
             <a:avLst/>
@@ -3389,14 +3608,14 @@
       </p:grpSpPr>
       <p:pic>
         <p:nvPicPr>
-          <p:cNvPr id="2" name="Image 0" descr="preencoded.png">    </p:cNvPr>
+          <p:cNvPr id="2" name="Image 0" descr="preencoded.png"/>
           <p:cNvPicPr>
             <a:picLocks noChangeAspect="1"/>
           </p:cNvPicPr>
           <p:nvPr/>
         </p:nvPicPr>
         <p:blipFill>
-          <a:blip r:embed="rId1"/>
+          <a:blip r:embed="rId3"/>
           <a:stretch>
             <a:fillRect/>
           </a:stretch>
@@ -3405,6 +3624,42 @@
           <a:xfrm>
             <a:off x="0" y="0"/>
             <a:ext cx="18288000" cy="10287000"/>
+          </a:xfrm>
+          <a:prstGeom prst="rect">
+            <a:avLst/>
+          </a:prstGeom>
+        </p:spPr>
+      </p:pic>
+      <p:pic>
+        <p:nvPicPr>
+          <p:cNvPr id="3" name="圖片 2">
+            <a:extLst>
+              <a:ext uri="{FF2B5EF4-FFF2-40B4-BE49-F238E27FC236}">
+                <a16:creationId xmlns:a16="http://schemas.microsoft.com/office/drawing/2014/main" id="{558DCFD9-8D9F-37B2-5982-2CD5C135794A}"/>
+              </a:ext>
+            </a:extLst>
+          </p:cNvPr>
+          <p:cNvPicPr>
+            <a:picLocks noChangeAspect="1"/>
+          </p:cNvPicPr>
+          <p:nvPr/>
+        </p:nvPicPr>
+        <p:blipFill>
+          <a:blip r:embed="rId4" cstate="print">
+            <a:extLst>
+              <a:ext uri="{28A0092B-C50C-407E-A947-70E740481C1C}">
+                <a14:useLocalDpi xmlns:a14="http://schemas.microsoft.com/office/drawing/2010/main" val="0"/>
+              </a:ext>
+            </a:extLst>
+          </a:blip>
+          <a:stretch>
+            <a:fillRect/>
+          </a:stretch>
+        </p:blipFill>
+        <p:spPr>
+          <a:xfrm>
+            <a:off x="16775324" y="9666655"/>
+            <a:ext cx="1368000" cy="620345"/>
           </a:xfrm>
           <a:prstGeom prst="rect">
             <a:avLst/>
@@ -3438,14 +3693,14 @@
       </p:grpSpPr>
       <p:pic>
         <p:nvPicPr>
-          <p:cNvPr id="2" name="Image 0" descr="preencoded.png">    </p:cNvPr>
+          <p:cNvPr id="2" name="Image 0" descr="preencoded.png"/>
           <p:cNvPicPr>
             <a:picLocks noChangeAspect="1"/>
           </p:cNvPicPr>
           <p:nvPr/>
         </p:nvPicPr>
         <p:blipFill>
-          <a:blip r:embed="rId1"/>
+          <a:blip r:embed="rId3"/>
           <a:stretch>
             <a:fillRect/>
           </a:stretch>
@@ -3454,6 +3709,42 @@
           <a:xfrm>
             <a:off x="0" y="0"/>
             <a:ext cx="18288000" cy="10287000"/>
+          </a:xfrm>
+          <a:prstGeom prst="rect">
+            <a:avLst/>
+          </a:prstGeom>
+        </p:spPr>
+      </p:pic>
+      <p:pic>
+        <p:nvPicPr>
+          <p:cNvPr id="3" name="圖片 2">
+            <a:extLst>
+              <a:ext uri="{FF2B5EF4-FFF2-40B4-BE49-F238E27FC236}">
+                <a16:creationId xmlns:a16="http://schemas.microsoft.com/office/drawing/2014/main" id="{F2C216FC-749F-392F-95B0-5CA8615B87D2}"/>
+              </a:ext>
+            </a:extLst>
+          </p:cNvPr>
+          <p:cNvPicPr>
+            <a:picLocks noChangeAspect="1"/>
+          </p:cNvPicPr>
+          <p:nvPr/>
+        </p:nvPicPr>
+        <p:blipFill>
+          <a:blip r:embed="rId4" cstate="print">
+            <a:extLst>
+              <a:ext uri="{28A0092B-C50C-407E-A947-70E740481C1C}">
+                <a14:useLocalDpi xmlns:a14="http://schemas.microsoft.com/office/drawing/2010/main" val="0"/>
+              </a:ext>
+            </a:extLst>
+          </a:blip>
+          <a:stretch>
+            <a:fillRect/>
+          </a:stretch>
+        </p:blipFill>
+        <p:spPr>
+          <a:xfrm>
+            <a:off x="16775324" y="9666655"/>
+            <a:ext cx="1368000" cy="620345"/>
           </a:xfrm>
           <a:prstGeom prst="rect">
             <a:avLst/>
@@ -3487,14 +3778,14 @@
       </p:grpSpPr>
       <p:pic>
         <p:nvPicPr>
-          <p:cNvPr id="2" name="Image 0" descr="preencoded.png">    </p:cNvPr>
+          <p:cNvPr id="2" name="Image 0" descr="preencoded.png"/>
           <p:cNvPicPr>
             <a:picLocks noChangeAspect="1"/>
           </p:cNvPicPr>
           <p:nvPr/>
         </p:nvPicPr>
         <p:blipFill>
-          <a:blip r:embed="rId1"/>
+          <a:blip r:embed="rId3"/>
           <a:stretch>
             <a:fillRect/>
           </a:stretch>
@@ -3503,6 +3794,42 @@
           <a:xfrm>
             <a:off x="0" y="0"/>
             <a:ext cx="18288000" cy="10287000"/>
+          </a:xfrm>
+          <a:prstGeom prst="rect">
+            <a:avLst/>
+          </a:prstGeom>
+        </p:spPr>
+      </p:pic>
+      <p:pic>
+        <p:nvPicPr>
+          <p:cNvPr id="3" name="圖片 2">
+            <a:extLst>
+              <a:ext uri="{FF2B5EF4-FFF2-40B4-BE49-F238E27FC236}">
+                <a16:creationId xmlns:a16="http://schemas.microsoft.com/office/drawing/2014/main" id="{D588D959-C116-93F8-9A38-619C7F9E131E}"/>
+              </a:ext>
+            </a:extLst>
+          </p:cNvPr>
+          <p:cNvPicPr>
+            <a:picLocks noChangeAspect="1"/>
+          </p:cNvPicPr>
+          <p:nvPr/>
+        </p:nvPicPr>
+        <p:blipFill>
+          <a:blip r:embed="rId4" cstate="print">
+            <a:extLst>
+              <a:ext uri="{28A0092B-C50C-407E-A947-70E740481C1C}">
+                <a14:useLocalDpi xmlns:a14="http://schemas.microsoft.com/office/drawing/2010/main" val="0"/>
+              </a:ext>
+            </a:extLst>
+          </a:blip>
+          <a:stretch>
+            <a:fillRect/>
+          </a:stretch>
+        </p:blipFill>
+        <p:spPr>
+          <a:xfrm>
+            <a:off x="16775324" y="9666655"/>
+            <a:ext cx="1368000" cy="620345"/>
           </a:xfrm>
           <a:prstGeom prst="rect">
             <a:avLst/>
@@ -3536,14 +3863,14 @@
       </p:grpSpPr>
       <p:pic>
         <p:nvPicPr>
-          <p:cNvPr id="2" name="Image 0" descr="preencoded.png">    </p:cNvPr>
+          <p:cNvPr id="2" name="Image 0" descr="preencoded.png"/>
           <p:cNvPicPr>
             <a:picLocks noChangeAspect="1"/>
           </p:cNvPicPr>
           <p:nvPr/>
         </p:nvPicPr>
         <p:blipFill>
-          <a:blip r:embed="rId1"/>
+          <a:blip r:embed="rId3"/>
           <a:stretch>
             <a:fillRect/>
           </a:stretch>
@@ -3552,6 +3879,42 @@
           <a:xfrm>
             <a:off x="0" y="0"/>
             <a:ext cx="18288000" cy="10287000"/>
+          </a:xfrm>
+          <a:prstGeom prst="rect">
+            <a:avLst/>
+          </a:prstGeom>
+        </p:spPr>
+      </p:pic>
+      <p:pic>
+        <p:nvPicPr>
+          <p:cNvPr id="3" name="圖片 2">
+            <a:extLst>
+              <a:ext uri="{FF2B5EF4-FFF2-40B4-BE49-F238E27FC236}">
+                <a16:creationId xmlns:a16="http://schemas.microsoft.com/office/drawing/2014/main" id="{399AA4E6-6A0C-C93E-A9E9-35D412FCC3A2}"/>
+              </a:ext>
+            </a:extLst>
+          </p:cNvPr>
+          <p:cNvPicPr>
+            <a:picLocks noChangeAspect="1"/>
+          </p:cNvPicPr>
+          <p:nvPr/>
+        </p:nvPicPr>
+        <p:blipFill>
+          <a:blip r:embed="rId4" cstate="print">
+            <a:extLst>
+              <a:ext uri="{28A0092B-C50C-407E-A947-70E740481C1C}">
+                <a14:useLocalDpi xmlns:a14="http://schemas.microsoft.com/office/drawing/2010/main" val="0"/>
+              </a:ext>
+            </a:extLst>
+          </a:blip>
+          <a:stretch>
+            <a:fillRect/>
+          </a:stretch>
+        </p:blipFill>
+        <p:spPr>
+          <a:xfrm>
+            <a:off x="16775324" y="9666655"/>
+            <a:ext cx="1368000" cy="620345"/>
           </a:xfrm>
           <a:prstGeom prst="rect">
             <a:avLst/>
@@ -3585,14 +3948,14 @@
       </p:grpSpPr>
       <p:pic>
         <p:nvPicPr>
-          <p:cNvPr id="2" name="Image 0" descr="preencoded.png">    </p:cNvPr>
+          <p:cNvPr id="2" name="Image 0" descr="preencoded.png"/>
           <p:cNvPicPr>
             <a:picLocks noChangeAspect="1"/>
           </p:cNvPicPr>
           <p:nvPr/>
         </p:nvPicPr>
         <p:blipFill>
-          <a:blip r:embed="rId1"/>
+          <a:blip r:embed="rId3"/>
           <a:stretch>
             <a:fillRect/>
           </a:stretch>
@@ -3601,6 +3964,42 @@
           <a:xfrm>
             <a:off x="0" y="0"/>
             <a:ext cx="18288000" cy="10287000"/>
+          </a:xfrm>
+          <a:prstGeom prst="rect">
+            <a:avLst/>
+          </a:prstGeom>
+        </p:spPr>
+      </p:pic>
+      <p:pic>
+        <p:nvPicPr>
+          <p:cNvPr id="3" name="圖片 2">
+            <a:extLst>
+              <a:ext uri="{FF2B5EF4-FFF2-40B4-BE49-F238E27FC236}">
+                <a16:creationId xmlns:a16="http://schemas.microsoft.com/office/drawing/2014/main" id="{9916182B-17F2-196C-F4B1-6719222CB261}"/>
+              </a:ext>
+            </a:extLst>
+          </p:cNvPr>
+          <p:cNvPicPr>
+            <a:picLocks noChangeAspect="1"/>
+          </p:cNvPicPr>
+          <p:nvPr/>
+        </p:nvPicPr>
+        <p:blipFill>
+          <a:blip r:embed="rId4" cstate="print">
+            <a:extLst>
+              <a:ext uri="{28A0092B-C50C-407E-A947-70E740481C1C}">
+                <a14:useLocalDpi xmlns:a14="http://schemas.microsoft.com/office/drawing/2010/main" val="0"/>
+              </a:ext>
+            </a:extLst>
+          </a:blip>
+          <a:stretch>
+            <a:fillRect/>
+          </a:stretch>
+        </p:blipFill>
+        <p:spPr>
+          <a:xfrm>
+            <a:off x="16775324" y="9666655"/>
+            <a:ext cx="1368000" cy="620345"/>
           </a:xfrm>
           <a:prstGeom prst="rect">
             <a:avLst/>
@@ -3634,14 +4033,14 @@
       </p:grpSpPr>
       <p:pic>
         <p:nvPicPr>
-          <p:cNvPr id="2" name="Image 0" descr="preencoded.png">    </p:cNvPr>
+          <p:cNvPr id="2" name="Image 0" descr="preencoded.png"/>
           <p:cNvPicPr>
             <a:picLocks noChangeAspect="1"/>
           </p:cNvPicPr>
           <p:nvPr/>
         </p:nvPicPr>
         <p:blipFill>
-          <a:blip r:embed="rId1"/>
+          <a:blip r:embed="rId3"/>
           <a:stretch>
             <a:fillRect/>
           </a:stretch>
@@ -3650,6 +4049,42 @@
           <a:xfrm>
             <a:off x="0" y="0"/>
             <a:ext cx="18288000" cy="10287000"/>
+          </a:xfrm>
+          <a:prstGeom prst="rect">
+            <a:avLst/>
+          </a:prstGeom>
+        </p:spPr>
+      </p:pic>
+      <p:pic>
+        <p:nvPicPr>
+          <p:cNvPr id="3" name="圖片 2">
+            <a:extLst>
+              <a:ext uri="{FF2B5EF4-FFF2-40B4-BE49-F238E27FC236}">
+                <a16:creationId xmlns:a16="http://schemas.microsoft.com/office/drawing/2014/main" id="{99497722-3F4F-8C4C-BFBE-F16484AED971}"/>
+              </a:ext>
+            </a:extLst>
+          </p:cNvPr>
+          <p:cNvPicPr>
+            <a:picLocks noChangeAspect="1"/>
+          </p:cNvPicPr>
+          <p:nvPr/>
+        </p:nvPicPr>
+        <p:blipFill>
+          <a:blip r:embed="rId4" cstate="print">
+            <a:extLst>
+              <a:ext uri="{28A0092B-C50C-407E-A947-70E740481C1C}">
+                <a14:useLocalDpi xmlns:a14="http://schemas.microsoft.com/office/drawing/2010/main" val="0"/>
+              </a:ext>
+            </a:extLst>
+          </a:blip>
+          <a:stretch>
+            <a:fillRect/>
+          </a:stretch>
+        </p:blipFill>
+        <p:spPr>
+          <a:xfrm>
+            <a:off x="16775324" y="9666655"/>
+            <a:ext cx="1368000" cy="620345"/>
           </a:xfrm>
           <a:prstGeom prst="rect">
             <a:avLst/>
@@ -3683,14 +4118,14 @@
       </p:grpSpPr>
       <p:pic>
         <p:nvPicPr>
-          <p:cNvPr id="2" name="Image 0" descr="preencoded.png">    </p:cNvPr>
+          <p:cNvPr id="2" name="Image 0" descr="preencoded.png"/>
           <p:cNvPicPr>
             <a:picLocks noChangeAspect="1"/>
           </p:cNvPicPr>
           <p:nvPr/>
         </p:nvPicPr>
         <p:blipFill>
-          <a:blip r:embed="rId1"/>
+          <a:blip r:embed="rId3"/>
           <a:stretch>
             <a:fillRect/>
           </a:stretch>
@@ -3699,6 +4134,42 @@
           <a:xfrm>
             <a:off x="0" y="0"/>
             <a:ext cx="18288000" cy="10287000"/>
+          </a:xfrm>
+          <a:prstGeom prst="rect">
+            <a:avLst/>
+          </a:prstGeom>
+        </p:spPr>
+      </p:pic>
+      <p:pic>
+        <p:nvPicPr>
+          <p:cNvPr id="3" name="圖片 2">
+            <a:extLst>
+              <a:ext uri="{FF2B5EF4-FFF2-40B4-BE49-F238E27FC236}">
+                <a16:creationId xmlns:a16="http://schemas.microsoft.com/office/drawing/2014/main" id="{8C47444C-CD11-A736-608B-587173FAA805}"/>
+              </a:ext>
+            </a:extLst>
+          </p:cNvPr>
+          <p:cNvPicPr>
+            <a:picLocks noChangeAspect="1"/>
+          </p:cNvPicPr>
+          <p:nvPr/>
+        </p:nvPicPr>
+        <p:blipFill>
+          <a:blip r:embed="rId4" cstate="print">
+            <a:extLst>
+              <a:ext uri="{28A0092B-C50C-407E-A947-70E740481C1C}">
+                <a14:useLocalDpi xmlns:a14="http://schemas.microsoft.com/office/drawing/2010/main" val="0"/>
+              </a:ext>
+            </a:extLst>
+          </a:blip>
+          <a:stretch>
+            <a:fillRect/>
+          </a:stretch>
+        </p:blipFill>
+        <p:spPr>
+          <a:xfrm>
+            <a:off x="16775324" y="9666655"/>
+            <a:ext cx="1368000" cy="620345"/>
           </a:xfrm>
           <a:prstGeom prst="rect">
             <a:avLst/>
@@ -3732,14 +4203,14 @@
       </p:grpSpPr>
       <p:pic>
         <p:nvPicPr>
-          <p:cNvPr id="2" name="Image 0" descr="preencoded.png">    </p:cNvPr>
+          <p:cNvPr id="2" name="Image 0" descr="preencoded.png"/>
           <p:cNvPicPr>
             <a:picLocks noChangeAspect="1"/>
           </p:cNvPicPr>
           <p:nvPr/>
         </p:nvPicPr>
         <p:blipFill>
-          <a:blip r:embed="rId1"/>
+          <a:blip r:embed="rId3"/>
           <a:stretch>
             <a:fillRect/>
           </a:stretch>
@@ -3748,6 +4219,42 @@
           <a:xfrm>
             <a:off x="0" y="0"/>
             <a:ext cx="18288000" cy="10287000"/>
+          </a:xfrm>
+          <a:prstGeom prst="rect">
+            <a:avLst/>
+          </a:prstGeom>
+        </p:spPr>
+      </p:pic>
+      <p:pic>
+        <p:nvPicPr>
+          <p:cNvPr id="3" name="圖片 2">
+            <a:extLst>
+              <a:ext uri="{FF2B5EF4-FFF2-40B4-BE49-F238E27FC236}">
+                <a16:creationId xmlns:a16="http://schemas.microsoft.com/office/drawing/2014/main" id="{E9A77D7D-48D0-74EC-94A3-3FF6AA0B2F22}"/>
+              </a:ext>
+            </a:extLst>
+          </p:cNvPr>
+          <p:cNvPicPr>
+            <a:picLocks noChangeAspect="1"/>
+          </p:cNvPicPr>
+          <p:nvPr/>
+        </p:nvPicPr>
+        <p:blipFill>
+          <a:blip r:embed="rId4" cstate="print">
+            <a:extLst>
+              <a:ext uri="{28A0092B-C50C-407E-A947-70E740481C1C}">
+                <a14:useLocalDpi xmlns:a14="http://schemas.microsoft.com/office/drawing/2010/main" val="0"/>
+              </a:ext>
+            </a:extLst>
+          </a:blip>
+          <a:stretch>
+            <a:fillRect/>
+          </a:stretch>
+        </p:blipFill>
+        <p:spPr>
+          <a:xfrm>
+            <a:off x="16775324" y="9666655"/>
+            <a:ext cx="1368000" cy="620345"/>
           </a:xfrm>
           <a:prstGeom prst="rect">
             <a:avLst/>
@@ -3781,14 +4288,14 @@
       </p:grpSpPr>
       <p:pic>
         <p:nvPicPr>
-          <p:cNvPr id="2" name="Image 0" descr="preencoded.png">    </p:cNvPr>
+          <p:cNvPr id="2" name="Image 0" descr="preencoded.png"/>
           <p:cNvPicPr>
             <a:picLocks noChangeAspect="1"/>
           </p:cNvPicPr>
           <p:nvPr/>
         </p:nvPicPr>
         <p:blipFill>
-          <a:blip r:embed="rId1"/>
+          <a:blip r:embed="rId3"/>
           <a:stretch>
             <a:fillRect/>
           </a:stretch>
@@ -3797,6 +4304,42 @@
           <a:xfrm>
             <a:off x="0" y="0"/>
             <a:ext cx="18288000" cy="10287000"/>
+          </a:xfrm>
+          <a:prstGeom prst="rect">
+            <a:avLst/>
+          </a:prstGeom>
+        </p:spPr>
+      </p:pic>
+      <p:pic>
+        <p:nvPicPr>
+          <p:cNvPr id="3" name="圖片 2">
+            <a:extLst>
+              <a:ext uri="{FF2B5EF4-FFF2-40B4-BE49-F238E27FC236}">
+                <a16:creationId xmlns:a16="http://schemas.microsoft.com/office/drawing/2014/main" id="{A05B475A-3FC1-F959-361B-5B455C3E3A34}"/>
+              </a:ext>
+            </a:extLst>
+          </p:cNvPr>
+          <p:cNvPicPr>
+            <a:picLocks noChangeAspect="1"/>
+          </p:cNvPicPr>
+          <p:nvPr/>
+        </p:nvPicPr>
+        <p:blipFill>
+          <a:blip r:embed="rId4" cstate="print">
+            <a:extLst>
+              <a:ext uri="{28A0092B-C50C-407E-A947-70E740481C1C}">
+                <a14:useLocalDpi xmlns:a14="http://schemas.microsoft.com/office/drawing/2010/main" val="0"/>
+              </a:ext>
+            </a:extLst>
+          </a:blip>
+          <a:stretch>
+            <a:fillRect/>
+          </a:stretch>
+        </p:blipFill>
+        <p:spPr>
+          <a:xfrm>
+            <a:off x="16775324" y="9666655"/>
+            <a:ext cx="1368000" cy="620345"/>
           </a:xfrm>
           <a:prstGeom prst="rect">
             <a:avLst/>
@@ -3830,14 +4373,14 @@
       </p:grpSpPr>
       <p:pic>
         <p:nvPicPr>
-          <p:cNvPr id="2" name="Image 0" descr="preencoded.png">    </p:cNvPr>
+          <p:cNvPr id="2" name="Image 0" descr="preencoded.png"/>
           <p:cNvPicPr>
             <a:picLocks noChangeAspect="1"/>
           </p:cNvPicPr>
           <p:nvPr/>
         </p:nvPicPr>
         <p:blipFill>
-          <a:blip r:embed="rId1"/>
+          <a:blip r:embed="rId3"/>
           <a:stretch>
             <a:fillRect/>
           </a:stretch>
@@ -3846,6 +4389,42 @@
           <a:xfrm>
             <a:off x="0" y="0"/>
             <a:ext cx="18288000" cy="10287000"/>
+          </a:xfrm>
+          <a:prstGeom prst="rect">
+            <a:avLst/>
+          </a:prstGeom>
+        </p:spPr>
+      </p:pic>
+      <p:pic>
+        <p:nvPicPr>
+          <p:cNvPr id="3" name="圖片 2">
+            <a:extLst>
+              <a:ext uri="{FF2B5EF4-FFF2-40B4-BE49-F238E27FC236}">
+                <a16:creationId xmlns:a16="http://schemas.microsoft.com/office/drawing/2014/main" id="{43B44012-46ED-E8C7-C55E-A247BADD852F}"/>
+              </a:ext>
+            </a:extLst>
+          </p:cNvPr>
+          <p:cNvPicPr>
+            <a:picLocks noChangeAspect="1"/>
+          </p:cNvPicPr>
+          <p:nvPr/>
+        </p:nvPicPr>
+        <p:blipFill>
+          <a:blip r:embed="rId4" cstate="print">
+            <a:extLst>
+              <a:ext uri="{28A0092B-C50C-407E-A947-70E740481C1C}">
+                <a14:useLocalDpi xmlns:a14="http://schemas.microsoft.com/office/drawing/2010/main" val="0"/>
+              </a:ext>
+            </a:extLst>
+          </a:blip>
+          <a:stretch>
+            <a:fillRect/>
+          </a:stretch>
+        </p:blipFill>
+        <p:spPr>
+          <a:xfrm>
+            <a:off x="16775324" y="9666655"/>
+            <a:ext cx="1368000" cy="620345"/>
           </a:xfrm>
           <a:prstGeom prst="rect">
             <a:avLst/>
@@ -3879,14 +4458,14 @@
       </p:grpSpPr>
       <p:pic>
         <p:nvPicPr>
-          <p:cNvPr id="2" name="Image 0" descr="preencoded.png">    </p:cNvPr>
+          <p:cNvPr id="2" name="Image 0" descr="preencoded.png"/>
           <p:cNvPicPr>
             <a:picLocks noChangeAspect="1"/>
           </p:cNvPicPr>
           <p:nvPr/>
         </p:nvPicPr>
         <p:blipFill>
-          <a:blip r:embed="rId1"/>
+          <a:blip r:embed="rId3"/>
           <a:stretch>
             <a:fillRect/>
           </a:stretch>
@@ -3895,6 +4474,42 @@
           <a:xfrm>
             <a:off x="0" y="0"/>
             <a:ext cx="18288000" cy="10287000"/>
+          </a:xfrm>
+          <a:prstGeom prst="rect">
+            <a:avLst/>
+          </a:prstGeom>
+        </p:spPr>
+      </p:pic>
+      <p:pic>
+        <p:nvPicPr>
+          <p:cNvPr id="3" name="圖片 2">
+            <a:extLst>
+              <a:ext uri="{FF2B5EF4-FFF2-40B4-BE49-F238E27FC236}">
+                <a16:creationId xmlns:a16="http://schemas.microsoft.com/office/drawing/2014/main" id="{B251B8C0-509C-CA3F-E0B5-BAAEC9988F38}"/>
+              </a:ext>
+            </a:extLst>
+          </p:cNvPr>
+          <p:cNvPicPr>
+            <a:picLocks noChangeAspect="1"/>
+          </p:cNvPicPr>
+          <p:nvPr/>
+        </p:nvPicPr>
+        <p:blipFill>
+          <a:blip r:embed="rId4" cstate="print">
+            <a:extLst>
+              <a:ext uri="{28A0092B-C50C-407E-A947-70E740481C1C}">
+                <a14:useLocalDpi xmlns:a14="http://schemas.microsoft.com/office/drawing/2010/main" val="0"/>
+              </a:ext>
+            </a:extLst>
+          </a:blip>
+          <a:stretch>
+            <a:fillRect/>
+          </a:stretch>
+        </p:blipFill>
+        <p:spPr>
+          <a:xfrm>
+            <a:off x="16775324" y="9666655"/>
+            <a:ext cx="1368000" cy="620345"/>
           </a:xfrm>
           <a:prstGeom prst="rect">
             <a:avLst/>
@@ -3928,14 +4543,14 @@
       </p:grpSpPr>
       <p:pic>
         <p:nvPicPr>
-          <p:cNvPr id="2" name="Image 0" descr="preencoded.png">    </p:cNvPr>
+          <p:cNvPr id="2" name="Image 0" descr="preencoded.png"/>
           <p:cNvPicPr>
             <a:picLocks noChangeAspect="1"/>
           </p:cNvPicPr>
           <p:nvPr/>
         </p:nvPicPr>
         <p:blipFill>
-          <a:blip r:embed="rId1"/>
+          <a:blip r:embed="rId3"/>
           <a:stretch>
             <a:fillRect/>
           </a:stretch>
@@ -3944,6 +4559,42 @@
           <a:xfrm>
             <a:off x="0" y="0"/>
             <a:ext cx="18288000" cy="10287000"/>
+          </a:xfrm>
+          <a:prstGeom prst="rect">
+            <a:avLst/>
+          </a:prstGeom>
+        </p:spPr>
+      </p:pic>
+      <p:pic>
+        <p:nvPicPr>
+          <p:cNvPr id="3" name="圖片 2">
+            <a:extLst>
+              <a:ext uri="{FF2B5EF4-FFF2-40B4-BE49-F238E27FC236}">
+                <a16:creationId xmlns:a16="http://schemas.microsoft.com/office/drawing/2014/main" id="{213E1263-5580-8896-CA0E-ED6D12675E10}"/>
+              </a:ext>
+            </a:extLst>
+          </p:cNvPr>
+          <p:cNvPicPr>
+            <a:picLocks noChangeAspect="1"/>
+          </p:cNvPicPr>
+          <p:nvPr/>
+        </p:nvPicPr>
+        <p:blipFill>
+          <a:blip r:embed="rId4" cstate="print">
+            <a:extLst>
+              <a:ext uri="{28A0092B-C50C-407E-A947-70E740481C1C}">
+                <a14:useLocalDpi xmlns:a14="http://schemas.microsoft.com/office/drawing/2010/main" val="0"/>
+              </a:ext>
+            </a:extLst>
+          </a:blip>
+          <a:stretch>
+            <a:fillRect/>
+          </a:stretch>
+        </p:blipFill>
+        <p:spPr>
+          <a:xfrm>
+            <a:off x="16775324" y="9666655"/>
+            <a:ext cx="1368000" cy="620345"/>
           </a:xfrm>
           <a:prstGeom prst="rect">
             <a:avLst/>
@@ -3977,14 +4628,14 @@
       </p:grpSpPr>
       <p:pic>
         <p:nvPicPr>
-          <p:cNvPr id="2" name="Image 0" descr="preencoded.png">    </p:cNvPr>
+          <p:cNvPr id="2" name="Image 0" descr="preencoded.png"/>
           <p:cNvPicPr>
             <a:picLocks noChangeAspect="1"/>
           </p:cNvPicPr>
           <p:nvPr/>
         </p:nvPicPr>
         <p:blipFill>
-          <a:blip r:embed="rId1"/>
+          <a:blip r:embed="rId3"/>
           <a:stretch>
             <a:fillRect/>
           </a:stretch>
@@ -3993,6 +4644,42 @@
           <a:xfrm>
             <a:off x="0" y="0"/>
             <a:ext cx="18288000" cy="10287000"/>
+          </a:xfrm>
+          <a:prstGeom prst="rect">
+            <a:avLst/>
+          </a:prstGeom>
+        </p:spPr>
+      </p:pic>
+      <p:pic>
+        <p:nvPicPr>
+          <p:cNvPr id="3" name="圖片 2">
+            <a:extLst>
+              <a:ext uri="{FF2B5EF4-FFF2-40B4-BE49-F238E27FC236}">
+                <a16:creationId xmlns:a16="http://schemas.microsoft.com/office/drawing/2014/main" id="{34248AF1-5C90-98ED-5679-E44A360B1743}"/>
+              </a:ext>
+            </a:extLst>
+          </p:cNvPr>
+          <p:cNvPicPr>
+            <a:picLocks noChangeAspect="1"/>
+          </p:cNvPicPr>
+          <p:nvPr/>
+        </p:nvPicPr>
+        <p:blipFill>
+          <a:blip r:embed="rId4" cstate="print">
+            <a:extLst>
+              <a:ext uri="{28A0092B-C50C-407E-A947-70E740481C1C}">
+                <a14:useLocalDpi xmlns:a14="http://schemas.microsoft.com/office/drawing/2010/main" val="0"/>
+              </a:ext>
+            </a:extLst>
+          </a:blip>
+          <a:stretch>
+            <a:fillRect/>
+          </a:stretch>
+        </p:blipFill>
+        <p:spPr>
+          <a:xfrm>
+            <a:off x="16775324" y="9666655"/>
+            <a:ext cx="1368000" cy="620345"/>
           </a:xfrm>
           <a:prstGeom prst="rect">
             <a:avLst/>
@@ -4026,14 +4713,14 @@
       </p:grpSpPr>
       <p:pic>
         <p:nvPicPr>
-          <p:cNvPr id="2" name="Image 0" descr="preencoded.png">    </p:cNvPr>
+          <p:cNvPr id="2" name="Image 0" descr="preencoded.png"/>
           <p:cNvPicPr>
             <a:picLocks noChangeAspect="1"/>
           </p:cNvPicPr>
           <p:nvPr/>
         </p:nvPicPr>
         <p:blipFill>
-          <a:blip r:embed="rId1"/>
+          <a:blip r:embed="rId3"/>
           <a:stretch>
             <a:fillRect/>
           </a:stretch>
@@ -4042,6 +4729,42 @@
           <a:xfrm>
             <a:off x="0" y="0"/>
             <a:ext cx="18288000" cy="10287000"/>
+          </a:xfrm>
+          <a:prstGeom prst="rect">
+            <a:avLst/>
+          </a:prstGeom>
+        </p:spPr>
+      </p:pic>
+      <p:pic>
+        <p:nvPicPr>
+          <p:cNvPr id="3" name="圖片 2">
+            <a:extLst>
+              <a:ext uri="{FF2B5EF4-FFF2-40B4-BE49-F238E27FC236}">
+                <a16:creationId xmlns:a16="http://schemas.microsoft.com/office/drawing/2014/main" id="{83F872BF-677D-30D4-6E62-DC7C080710ED}"/>
+              </a:ext>
+            </a:extLst>
+          </p:cNvPr>
+          <p:cNvPicPr>
+            <a:picLocks noChangeAspect="1"/>
+          </p:cNvPicPr>
+          <p:nvPr/>
+        </p:nvPicPr>
+        <p:blipFill>
+          <a:blip r:embed="rId4" cstate="print">
+            <a:extLst>
+              <a:ext uri="{28A0092B-C50C-407E-A947-70E740481C1C}">
+                <a14:useLocalDpi xmlns:a14="http://schemas.microsoft.com/office/drawing/2010/main" val="0"/>
+              </a:ext>
+            </a:extLst>
+          </a:blip>
+          <a:stretch>
+            <a:fillRect/>
+          </a:stretch>
+        </p:blipFill>
+        <p:spPr>
+          <a:xfrm>
+            <a:off x="16775324" y="9666655"/>
+            <a:ext cx="1368000" cy="620345"/>
           </a:xfrm>
           <a:prstGeom prst="rect">
             <a:avLst/>
@@ -4075,14 +4798,14 @@
       </p:grpSpPr>
       <p:pic>
         <p:nvPicPr>
-          <p:cNvPr id="2" name="Image 0" descr="preencoded.png">    </p:cNvPr>
+          <p:cNvPr id="2" name="Image 0" descr="preencoded.png"/>
           <p:cNvPicPr>
             <a:picLocks noChangeAspect="1"/>
           </p:cNvPicPr>
           <p:nvPr/>
         </p:nvPicPr>
         <p:blipFill>
-          <a:blip r:embed="rId1"/>
+          <a:blip r:embed="rId3"/>
           <a:stretch>
             <a:fillRect/>
           </a:stretch>
@@ -4091,6 +4814,42 @@
           <a:xfrm>
             <a:off x="0" y="0"/>
             <a:ext cx="18288000" cy="10287000"/>
+          </a:xfrm>
+          <a:prstGeom prst="rect">
+            <a:avLst/>
+          </a:prstGeom>
+        </p:spPr>
+      </p:pic>
+      <p:pic>
+        <p:nvPicPr>
+          <p:cNvPr id="3" name="圖片 2">
+            <a:extLst>
+              <a:ext uri="{FF2B5EF4-FFF2-40B4-BE49-F238E27FC236}">
+                <a16:creationId xmlns:a16="http://schemas.microsoft.com/office/drawing/2014/main" id="{C2CB5457-9195-FA7F-D85A-EC8670204876}"/>
+              </a:ext>
+            </a:extLst>
+          </p:cNvPr>
+          <p:cNvPicPr>
+            <a:picLocks noChangeAspect="1"/>
+          </p:cNvPicPr>
+          <p:nvPr/>
+        </p:nvPicPr>
+        <p:blipFill>
+          <a:blip r:embed="rId4" cstate="print">
+            <a:extLst>
+              <a:ext uri="{28A0092B-C50C-407E-A947-70E740481C1C}">
+                <a14:useLocalDpi xmlns:a14="http://schemas.microsoft.com/office/drawing/2010/main" val="0"/>
+              </a:ext>
+            </a:extLst>
+          </a:blip>
+          <a:stretch>
+            <a:fillRect/>
+          </a:stretch>
+        </p:blipFill>
+        <p:spPr>
+          <a:xfrm>
+            <a:off x="16775324" y="9666655"/>
+            <a:ext cx="1368000" cy="620345"/>
           </a:xfrm>
           <a:prstGeom prst="rect">
             <a:avLst/>
@@ -4124,14 +4883,14 @@
       </p:grpSpPr>
       <p:pic>
         <p:nvPicPr>
-          <p:cNvPr id="2" name="Image 0" descr="preencoded.png">    </p:cNvPr>
+          <p:cNvPr id="2" name="Image 0" descr="preencoded.png"/>
           <p:cNvPicPr>
             <a:picLocks noChangeAspect="1"/>
           </p:cNvPicPr>
           <p:nvPr/>
         </p:nvPicPr>
         <p:blipFill>
-          <a:blip r:embed="rId1"/>
+          <a:blip r:embed="rId3"/>
           <a:stretch>
             <a:fillRect/>
           </a:stretch>
@@ -4140,6 +4899,42 @@
           <a:xfrm>
             <a:off x="0" y="0"/>
             <a:ext cx="18288000" cy="10287000"/>
+          </a:xfrm>
+          <a:prstGeom prst="rect">
+            <a:avLst/>
+          </a:prstGeom>
+        </p:spPr>
+      </p:pic>
+      <p:pic>
+        <p:nvPicPr>
+          <p:cNvPr id="3" name="圖片 2">
+            <a:extLst>
+              <a:ext uri="{FF2B5EF4-FFF2-40B4-BE49-F238E27FC236}">
+                <a16:creationId xmlns:a16="http://schemas.microsoft.com/office/drawing/2014/main" id="{DE4F0632-39EE-CFAA-5B0B-30F01059795D}"/>
+              </a:ext>
+            </a:extLst>
+          </p:cNvPr>
+          <p:cNvPicPr>
+            <a:picLocks noChangeAspect="1"/>
+          </p:cNvPicPr>
+          <p:nvPr/>
+        </p:nvPicPr>
+        <p:blipFill>
+          <a:blip r:embed="rId4" cstate="print">
+            <a:extLst>
+              <a:ext uri="{28A0092B-C50C-407E-A947-70E740481C1C}">
+                <a14:useLocalDpi xmlns:a14="http://schemas.microsoft.com/office/drawing/2010/main" val="0"/>
+              </a:ext>
+            </a:extLst>
+          </a:blip>
+          <a:stretch>
+            <a:fillRect/>
+          </a:stretch>
+        </p:blipFill>
+        <p:spPr>
+          <a:xfrm>
+            <a:off x="16775324" y="9666655"/>
+            <a:ext cx="1368000" cy="620345"/>
           </a:xfrm>
           <a:prstGeom prst="rect">
             <a:avLst/>
@@ -4173,14 +4968,14 @@
       </p:grpSpPr>
       <p:pic>
         <p:nvPicPr>
-          <p:cNvPr id="2" name="Image 0" descr="preencoded.png">    </p:cNvPr>
+          <p:cNvPr id="2" name="Image 0" descr="preencoded.png"/>
           <p:cNvPicPr>
             <a:picLocks noChangeAspect="1"/>
           </p:cNvPicPr>
           <p:nvPr/>
         </p:nvPicPr>
         <p:blipFill>
-          <a:blip r:embed="rId1"/>
+          <a:blip r:embed="rId3"/>
           <a:stretch>
             <a:fillRect/>
           </a:stretch>
@@ -4189,6 +4984,42 @@
           <a:xfrm>
             <a:off x="0" y="0"/>
             <a:ext cx="18288000" cy="10287000"/>
+          </a:xfrm>
+          <a:prstGeom prst="rect">
+            <a:avLst/>
+          </a:prstGeom>
+        </p:spPr>
+      </p:pic>
+      <p:pic>
+        <p:nvPicPr>
+          <p:cNvPr id="3" name="圖片 2">
+            <a:extLst>
+              <a:ext uri="{FF2B5EF4-FFF2-40B4-BE49-F238E27FC236}">
+                <a16:creationId xmlns:a16="http://schemas.microsoft.com/office/drawing/2014/main" id="{48B5664E-DFD5-55F7-C972-6B49C5369F9E}"/>
+              </a:ext>
+            </a:extLst>
+          </p:cNvPr>
+          <p:cNvPicPr>
+            <a:picLocks noChangeAspect="1"/>
+          </p:cNvPicPr>
+          <p:nvPr/>
+        </p:nvPicPr>
+        <p:blipFill>
+          <a:blip r:embed="rId4" cstate="print">
+            <a:extLst>
+              <a:ext uri="{28A0092B-C50C-407E-A947-70E740481C1C}">
+                <a14:useLocalDpi xmlns:a14="http://schemas.microsoft.com/office/drawing/2010/main" val="0"/>
+              </a:ext>
+            </a:extLst>
+          </a:blip>
+          <a:stretch>
+            <a:fillRect/>
+          </a:stretch>
+        </p:blipFill>
+        <p:spPr>
+          <a:xfrm>
+            <a:off x="16775324" y="9666655"/>
+            <a:ext cx="1368000" cy="620345"/>
           </a:xfrm>
           <a:prstGeom prst="rect">
             <a:avLst/>
@@ -4222,14 +5053,14 @@
       </p:grpSpPr>
       <p:pic>
         <p:nvPicPr>
-          <p:cNvPr id="2" name="Image 0" descr="preencoded.png">    </p:cNvPr>
+          <p:cNvPr id="2" name="Image 0" descr="preencoded.png"/>
           <p:cNvPicPr>
             <a:picLocks noChangeAspect="1"/>
           </p:cNvPicPr>
           <p:nvPr/>
         </p:nvPicPr>
         <p:blipFill>
-          <a:blip r:embed="rId1"/>
+          <a:blip r:embed="rId3"/>
           <a:stretch>
             <a:fillRect/>
           </a:stretch>
@@ -4238,6 +5069,42 @@
           <a:xfrm>
             <a:off x="0" y="0"/>
             <a:ext cx="18288000" cy="10287000"/>
+          </a:xfrm>
+          <a:prstGeom prst="rect">
+            <a:avLst/>
+          </a:prstGeom>
+        </p:spPr>
+      </p:pic>
+      <p:pic>
+        <p:nvPicPr>
+          <p:cNvPr id="3" name="圖片 2">
+            <a:extLst>
+              <a:ext uri="{FF2B5EF4-FFF2-40B4-BE49-F238E27FC236}">
+                <a16:creationId xmlns:a16="http://schemas.microsoft.com/office/drawing/2014/main" id="{EBB0709D-1B1F-9367-57DB-FB56080429DE}"/>
+              </a:ext>
+            </a:extLst>
+          </p:cNvPr>
+          <p:cNvPicPr>
+            <a:picLocks noChangeAspect="1"/>
+          </p:cNvPicPr>
+          <p:nvPr/>
+        </p:nvPicPr>
+        <p:blipFill>
+          <a:blip r:embed="rId4" cstate="print">
+            <a:extLst>
+              <a:ext uri="{28A0092B-C50C-407E-A947-70E740481C1C}">
+                <a14:useLocalDpi xmlns:a14="http://schemas.microsoft.com/office/drawing/2010/main" val="0"/>
+              </a:ext>
+            </a:extLst>
+          </a:blip>
+          <a:stretch>
+            <a:fillRect/>
+          </a:stretch>
+        </p:blipFill>
+        <p:spPr>
+          <a:xfrm>
+            <a:off x="16775324" y="9666655"/>
+            <a:ext cx="1368000" cy="620345"/>
           </a:xfrm>
           <a:prstGeom prst="rect">
             <a:avLst/>
@@ -4271,14 +5138,14 @@
       </p:grpSpPr>
       <p:pic>
         <p:nvPicPr>
-          <p:cNvPr id="2" name="Image 0" descr="preencoded.png">    </p:cNvPr>
+          <p:cNvPr id="2" name="Image 0" descr="preencoded.png"/>
           <p:cNvPicPr>
             <a:picLocks noChangeAspect="1"/>
           </p:cNvPicPr>
           <p:nvPr/>
         </p:nvPicPr>
         <p:blipFill>
-          <a:blip r:embed="rId1"/>
+          <a:blip r:embed="rId3"/>
           <a:stretch>
             <a:fillRect/>
           </a:stretch>
@@ -4287,6 +5154,42 @@
           <a:xfrm>
             <a:off x="0" y="0"/>
             <a:ext cx="18288000" cy="10287000"/>
+          </a:xfrm>
+          <a:prstGeom prst="rect">
+            <a:avLst/>
+          </a:prstGeom>
+        </p:spPr>
+      </p:pic>
+      <p:pic>
+        <p:nvPicPr>
+          <p:cNvPr id="3" name="圖片 2">
+            <a:extLst>
+              <a:ext uri="{FF2B5EF4-FFF2-40B4-BE49-F238E27FC236}">
+                <a16:creationId xmlns:a16="http://schemas.microsoft.com/office/drawing/2014/main" id="{B4552C52-6F56-2B98-2EBF-8ACC5C62E351}"/>
+              </a:ext>
+            </a:extLst>
+          </p:cNvPr>
+          <p:cNvPicPr>
+            <a:picLocks noChangeAspect="1"/>
+          </p:cNvPicPr>
+          <p:nvPr/>
+        </p:nvPicPr>
+        <p:blipFill>
+          <a:blip r:embed="rId4" cstate="print">
+            <a:extLst>
+              <a:ext uri="{28A0092B-C50C-407E-A947-70E740481C1C}">
+                <a14:useLocalDpi xmlns:a14="http://schemas.microsoft.com/office/drawing/2010/main" val="0"/>
+              </a:ext>
+            </a:extLst>
+          </a:blip>
+          <a:stretch>
+            <a:fillRect/>
+          </a:stretch>
+        </p:blipFill>
+        <p:spPr>
+          <a:xfrm>
+            <a:off x="16775324" y="9666655"/>
+            <a:ext cx="1368000" cy="620345"/>
           </a:xfrm>
           <a:prstGeom prst="rect">
             <a:avLst/>
@@ -4320,14 +5223,14 @@
       </p:grpSpPr>
       <p:pic>
         <p:nvPicPr>
-          <p:cNvPr id="2" name="Image 0" descr="preencoded.png">    </p:cNvPr>
+          <p:cNvPr id="2" name="Image 0" descr="preencoded.png"/>
           <p:cNvPicPr>
             <a:picLocks noChangeAspect="1"/>
           </p:cNvPicPr>
           <p:nvPr/>
         </p:nvPicPr>
         <p:blipFill>
-          <a:blip r:embed="rId1"/>
+          <a:blip r:embed="rId3"/>
           <a:stretch>
             <a:fillRect/>
           </a:stretch>
@@ -4336,6 +5239,42 @@
           <a:xfrm>
             <a:off x="0" y="0"/>
             <a:ext cx="18288000" cy="10287000"/>
+          </a:xfrm>
+          <a:prstGeom prst="rect">
+            <a:avLst/>
+          </a:prstGeom>
+        </p:spPr>
+      </p:pic>
+      <p:pic>
+        <p:nvPicPr>
+          <p:cNvPr id="3" name="圖片 2">
+            <a:extLst>
+              <a:ext uri="{FF2B5EF4-FFF2-40B4-BE49-F238E27FC236}">
+                <a16:creationId xmlns:a16="http://schemas.microsoft.com/office/drawing/2014/main" id="{906B9969-537D-62D0-7CFB-8584AAA2F709}"/>
+              </a:ext>
+            </a:extLst>
+          </p:cNvPr>
+          <p:cNvPicPr>
+            <a:picLocks noChangeAspect="1"/>
+          </p:cNvPicPr>
+          <p:nvPr/>
+        </p:nvPicPr>
+        <p:blipFill>
+          <a:blip r:embed="rId4" cstate="print">
+            <a:extLst>
+              <a:ext uri="{28A0092B-C50C-407E-A947-70E740481C1C}">
+                <a14:useLocalDpi xmlns:a14="http://schemas.microsoft.com/office/drawing/2010/main" val="0"/>
+              </a:ext>
+            </a:extLst>
+          </a:blip>
+          <a:stretch>
+            <a:fillRect/>
+          </a:stretch>
+        </p:blipFill>
+        <p:spPr>
+          <a:xfrm>
+            <a:off x="16775324" y="9666655"/>
+            <a:ext cx="1368000" cy="620345"/>
           </a:xfrm>
           <a:prstGeom prst="rect">
             <a:avLst/>
@@ -4643,4 +5582,319 @@
     </a:ext>
   </a:extLst>
 </a:theme>
+</file>
+
+<file path=ppt/theme/theme2.xml><?xml version="1.0" encoding="utf-8"?>
+<a:theme xmlns:a="http://schemas.openxmlformats.org/drawingml/2006/main" name="Office 佈景主題">
+  <a:themeElements>
+    <a:clrScheme name="Office">
+      <a:dk1>
+        <a:sysClr val="windowText" lastClr="000000"/>
+      </a:dk1>
+      <a:lt1>
+        <a:sysClr val="window" lastClr="FFFFFF"/>
+      </a:lt1>
+      <a:dk2>
+        <a:srgbClr val="0E2841"/>
+      </a:dk2>
+      <a:lt2>
+        <a:srgbClr val="E8E8E8"/>
+      </a:lt2>
+      <a:accent1>
+        <a:srgbClr val="156082"/>
+      </a:accent1>
+      <a:accent2>
+        <a:srgbClr val="E97132"/>
+      </a:accent2>
+      <a:accent3>
+        <a:srgbClr val="196B24"/>
+      </a:accent3>
+      <a:accent4>
+        <a:srgbClr val="0F9ED5"/>
+      </a:accent4>
+      <a:accent5>
+        <a:srgbClr val="A02B93"/>
+      </a:accent5>
+      <a:accent6>
+        <a:srgbClr val="4EA72E"/>
+      </a:accent6>
+      <a:hlink>
+        <a:srgbClr val="467886"/>
+      </a:hlink>
+      <a:folHlink>
+        <a:srgbClr val="96607D"/>
+      </a:folHlink>
+    </a:clrScheme>
+    <a:fontScheme name="Office">
+      <a:majorFont>
+        <a:latin typeface="Aptos Display" panose="02110004020202020204"/>
+        <a:ea typeface=""/>
+        <a:cs typeface=""/>
+        <a:font script="Jpan" typeface="游ゴシック Light"/>
+        <a:font script="Hang" typeface="맑은 고딕"/>
+        <a:font script="Hans" typeface="等线 Light"/>
+        <a:font script="Hant" typeface="新細明體"/>
+        <a:font script="Arab" typeface="Times New Roman"/>
+        <a:font script="Hebr" typeface="Times New Roman"/>
+        <a:font script="Thai" typeface="Angsana New"/>
+        <a:font script="Ethi" typeface="Nyala"/>
+        <a:font script="Beng" typeface="Vrinda"/>
+        <a:font script="Gujr" typeface="Shruti"/>
+        <a:font script="Khmr" typeface="MoolBoran"/>
+        <a:font script="Knda" typeface="Tunga"/>
+        <a:font script="Guru" typeface="Raavi"/>
+        <a:font script="Cans" typeface="Euphemia"/>
+        <a:font script="Cher" typeface="Plantagenet Cherokee"/>
+        <a:font script="Yiii" typeface="Microsoft Yi Baiti"/>
+        <a:font script="Tibt" typeface="Microsoft Himalaya"/>
+        <a:font script="Thaa" typeface="MV Boli"/>
+        <a:font script="Deva" typeface="Mangal"/>
+        <a:font script="Telu" typeface="Gautami"/>
+        <a:font script="Taml" typeface="Latha"/>
+        <a:font script="Syrc" typeface="Estrangelo Edessa"/>
+        <a:font script="Orya" typeface="Kalinga"/>
+        <a:font script="Mlym" typeface="Kartika"/>
+        <a:font script="Laoo" typeface="DokChampa"/>
+        <a:font script="Sinh" typeface="Iskoola Pota"/>
+        <a:font script="Mong" typeface="Mongolian Baiti"/>
+        <a:font script="Viet" typeface="Times New Roman"/>
+        <a:font script="Uigh" typeface="Microsoft Uighur"/>
+        <a:font script="Geor" typeface="Sylfaen"/>
+        <a:font script="Armn" typeface="Arial"/>
+        <a:font script="Bugi" typeface="Leelawadee UI"/>
+        <a:font script="Bopo" typeface="Microsoft JhengHei"/>
+        <a:font script="Java" typeface="Javanese Text"/>
+        <a:font script="Lisu" typeface="Segoe UI"/>
+        <a:font script="Mymr" typeface="Myanmar Text"/>
+        <a:font script="Nkoo" typeface="Ebrima"/>
+        <a:font script="Olck" typeface="Nirmala UI"/>
+        <a:font script="Osma" typeface="Ebrima"/>
+        <a:font script="Phag" typeface="Phagspa"/>
+        <a:font script="Syrn" typeface="Estrangelo Edessa"/>
+        <a:font script="Syrj" typeface="Estrangelo Edessa"/>
+        <a:font script="Syre" typeface="Estrangelo Edessa"/>
+        <a:font script="Sora" typeface="Nirmala UI"/>
+        <a:font script="Tale" typeface="Microsoft Tai Le"/>
+        <a:font script="Talu" typeface="Microsoft New Tai Lue"/>
+        <a:font script="Tfng" typeface="Ebrima"/>
+      </a:majorFont>
+      <a:minorFont>
+        <a:latin typeface="Aptos" panose="02110004020202020204"/>
+        <a:ea typeface=""/>
+        <a:cs typeface=""/>
+        <a:font script="Jpan" typeface="游ゴシック"/>
+        <a:font script="Hang" typeface="맑은 고딕"/>
+        <a:font script="Hans" typeface="等线"/>
+        <a:font script="Hant" typeface="新細明體"/>
+        <a:font script="Arab" typeface="Arial"/>
+        <a:font script="Hebr" typeface="Arial"/>
+        <a:font script="Thai" typeface="Cordia New"/>
+        <a:font script="Ethi" typeface="Nyala"/>
+        <a:font script="Beng" typeface="Vrinda"/>
+        <a:font script="Gujr" typeface="Shruti"/>
+        <a:font script="Khmr" typeface="DaunPenh"/>
+        <a:font script="Knda" typeface="Tunga"/>
+        <a:font script="Guru" typeface="Raavi"/>
+        <a:font script="Cans" typeface="Euphemia"/>
+        <a:font script="Cher" typeface="Plantagenet Cherokee"/>
+        <a:font script="Yiii" typeface="Microsoft Yi Baiti"/>
+        <a:font script="Tibt" typeface="Microsoft Himalaya"/>
+        <a:font script="Thaa" typeface="MV Boli"/>
+        <a:font script="Deva" typeface="Mangal"/>
+        <a:font script="Telu" typeface="Gautami"/>
+        <a:font script="Taml" typeface="Latha"/>
+        <a:font script="Syrc" typeface="Estrangelo Edessa"/>
+        <a:font script="Orya" typeface="Kalinga"/>
+        <a:font script="Mlym" typeface="Kartika"/>
+        <a:font script="Laoo" typeface="DokChampa"/>
+        <a:font script="Sinh" typeface="Iskoola Pota"/>
+        <a:font script="Mong" typeface="Mongolian Baiti"/>
+        <a:font script="Viet" typeface="Arial"/>
+        <a:font script="Uigh" typeface="Microsoft Uighur"/>
+        <a:font script="Geor" typeface="Sylfaen"/>
+        <a:font script="Armn" typeface="Arial"/>
+        <a:font script="Bugi" typeface="Leelawadee UI"/>
+        <a:font script="Bopo" typeface="Microsoft JhengHei"/>
+        <a:font script="Java" typeface="Javanese Text"/>
+        <a:font script="Lisu" typeface="Segoe UI"/>
+        <a:font script="Mymr" typeface="Myanmar Text"/>
+        <a:font script="Nkoo" typeface="Ebrima"/>
+        <a:font script="Olck" typeface="Nirmala UI"/>
+        <a:font script="Osma" typeface="Ebrima"/>
+        <a:font script="Phag" typeface="Phagspa"/>
+        <a:font script="Syrn" typeface="Estrangelo Edessa"/>
+        <a:font script="Syrj" typeface="Estrangelo Edessa"/>
+        <a:font script="Syre" typeface="Estrangelo Edessa"/>
+        <a:font script="Sora" typeface="Nirmala UI"/>
+        <a:font script="Tale" typeface="Microsoft Tai Le"/>
+        <a:font script="Talu" typeface="Microsoft New Tai Lue"/>
+        <a:font script="Tfng" typeface="Ebrima"/>
+      </a:minorFont>
+    </a:fontScheme>
+    <a:fmtScheme name="Office">
+      <a:fillStyleLst>
+        <a:solidFill>
+          <a:schemeClr val="phClr"/>
+        </a:solidFill>
+        <a:gradFill rotWithShape="1">
+          <a:gsLst>
+            <a:gs pos="0">
+              <a:schemeClr val="phClr">
+                <a:lumMod val="110000"/>
+                <a:satMod val="105000"/>
+                <a:tint val="67000"/>
+              </a:schemeClr>
+            </a:gs>
+            <a:gs pos="50000">
+              <a:schemeClr val="phClr">
+                <a:lumMod val="105000"/>
+                <a:satMod val="103000"/>
+                <a:tint val="73000"/>
+              </a:schemeClr>
+            </a:gs>
+            <a:gs pos="100000">
+              <a:schemeClr val="phClr">
+                <a:lumMod val="105000"/>
+                <a:satMod val="109000"/>
+                <a:tint val="81000"/>
+              </a:schemeClr>
+            </a:gs>
+          </a:gsLst>
+          <a:lin ang="5400000" scaled="0"/>
+        </a:gradFill>
+        <a:gradFill rotWithShape="1">
+          <a:gsLst>
+            <a:gs pos="0">
+              <a:schemeClr val="phClr">
+                <a:satMod val="103000"/>
+                <a:lumMod val="102000"/>
+                <a:tint val="94000"/>
+              </a:schemeClr>
+            </a:gs>
+            <a:gs pos="50000">
+              <a:schemeClr val="phClr">
+                <a:satMod val="110000"/>
+                <a:lumMod val="100000"/>
+                <a:shade val="100000"/>
+              </a:schemeClr>
+            </a:gs>
+            <a:gs pos="100000">
+              <a:schemeClr val="phClr">
+                <a:lumMod val="99000"/>
+                <a:satMod val="120000"/>
+                <a:shade val="78000"/>
+              </a:schemeClr>
+            </a:gs>
+          </a:gsLst>
+          <a:lin ang="5400000" scaled="0"/>
+        </a:gradFill>
+      </a:fillStyleLst>
+      <a:lnStyleLst>
+        <a:ln w="12700" cap="flat" cmpd="sng" algn="ctr">
+          <a:solidFill>
+            <a:schemeClr val="phClr"/>
+          </a:solidFill>
+          <a:prstDash val="solid"/>
+          <a:miter lim="800000"/>
+        </a:ln>
+        <a:ln w="19050" cap="flat" cmpd="sng" algn="ctr">
+          <a:solidFill>
+            <a:schemeClr val="phClr"/>
+          </a:solidFill>
+          <a:prstDash val="solid"/>
+          <a:miter lim="800000"/>
+        </a:ln>
+        <a:ln w="25400" cap="flat" cmpd="sng" algn="ctr">
+          <a:solidFill>
+            <a:schemeClr val="phClr"/>
+          </a:solidFill>
+          <a:prstDash val="solid"/>
+          <a:miter lim="800000"/>
+        </a:ln>
+      </a:lnStyleLst>
+      <a:effectStyleLst>
+        <a:effectStyle>
+          <a:effectLst/>
+        </a:effectStyle>
+        <a:effectStyle>
+          <a:effectLst/>
+        </a:effectStyle>
+        <a:effectStyle>
+          <a:effectLst>
+            <a:outerShdw blurRad="57150" dist="19050" dir="5400000" algn="ctr" rotWithShape="0">
+              <a:srgbClr val="000000">
+                <a:alpha val="63000"/>
+              </a:srgbClr>
+            </a:outerShdw>
+          </a:effectLst>
+        </a:effectStyle>
+      </a:effectStyleLst>
+      <a:bgFillStyleLst>
+        <a:solidFill>
+          <a:schemeClr val="phClr"/>
+        </a:solidFill>
+        <a:solidFill>
+          <a:schemeClr val="phClr">
+            <a:tint val="95000"/>
+            <a:satMod val="170000"/>
+          </a:schemeClr>
+        </a:solidFill>
+        <a:gradFill rotWithShape="1">
+          <a:gsLst>
+            <a:gs pos="0">
+              <a:schemeClr val="phClr">
+                <a:tint val="93000"/>
+                <a:satMod val="150000"/>
+                <a:shade val="98000"/>
+                <a:lumMod val="102000"/>
+              </a:schemeClr>
+            </a:gs>
+            <a:gs pos="50000">
+              <a:schemeClr val="phClr">
+                <a:tint val="98000"/>
+                <a:satMod val="130000"/>
+                <a:shade val="90000"/>
+                <a:lumMod val="103000"/>
+              </a:schemeClr>
+            </a:gs>
+            <a:gs pos="100000">
+              <a:schemeClr val="phClr">
+                <a:shade val="63000"/>
+                <a:satMod val="120000"/>
+              </a:schemeClr>
+            </a:gs>
+          </a:gsLst>
+          <a:lin ang="5400000" scaled="0"/>
+        </a:gradFill>
+      </a:bgFillStyleLst>
+    </a:fmtScheme>
+  </a:themeElements>
+  <a:objectDefaults>
+    <a:lnDef>
+      <a:spPr/>
+      <a:bodyPr/>
+      <a:lstStyle/>
+      <a:style>
+        <a:lnRef idx="2">
+          <a:schemeClr val="accent1"/>
+        </a:lnRef>
+        <a:fillRef idx="0">
+          <a:schemeClr val="accent1"/>
+        </a:fillRef>
+        <a:effectRef idx="1">
+          <a:schemeClr val="accent1"/>
+        </a:effectRef>
+        <a:fontRef idx="minor">
+          <a:schemeClr val="tx1"/>
+        </a:fontRef>
+      </a:style>
+    </a:lnDef>
+  </a:objectDefaults>
+  <a:extraClrSchemeLst/>
+  <a:extLst>
+    <a:ext uri="{05A4C25C-085E-4340-85A3-A5531E510DB2}">
+      <thm15:themeFamily xmlns:thm15="http://schemas.microsoft.com/office/thememl/2012/main" name="Office Theme" id="{2E142A2C-CD16-42D6-873A-C26D2A0506FA}" vid="{1BDDFF52-6CD6-40A5-AB3C-68EB2F1E4D0A}"/>
+    </a:ext>
+  </a:extLst>
+</a:theme>
 </file>
</xml_diff>